<commit_message>
Summary deck: SkillAIbility intro slide + QR code
Co-Authored-By: Claude Fable 5.1 <noreply@anthropic.com>
Claude-Session: https://claude.ai/code/session_01P7o6S9R44PVqU2edRj877h
</commit_message>
<xml_diff>
--- a/docs/SkillAIbility_WP3_Chalmers_Contribution_Summary.pptx
+++ b/docs/SkillAIbility_WP3_Chalmers_Contribution_Summary.pptx
@@ -12,6 +12,7 @@
   </p:handoutMasterIdLst>
   <p:sldIdLst>
     <p:sldId id="256" r:id="rId14"/>
+    <p:sldId id="257" r:id="rId15"/>
   </p:sldIdLst>
   <p:sldSz cx="12192000" cy="6858000"/>
   <p:notesSz cx="6858000" cy="9144000"/>
@@ -7288,7 +7289,7 @@
           <a:lstStyle/>
           <a:p>
             <a:r>
-              <a:t>Chalmers contribution to WP3</a:t>
+              <a:t>SkillAIbility at a glance</a:t>
             </a:r>
           </a:p>
         </p:txBody>
@@ -7302,7 +7303,7 @@
         <p:spPr>
           <a:xfrm>
             <a:off x="896112" y="1261872"/>
-            <a:ext cx="10332720" cy="365760"/>
+            <a:ext cx="10332720" cy="502920"/>
           </a:xfrm>
           <a:prstGeom prst="rect">
             <a:avLst/>
@@ -7321,12 +7322,12 @@
               </a:spcAft>
             </a:pPr>
             <a:r>
-              <a:rPr sz="1200" b="0" i="1">
+              <a:rPr sz="1150" b="0" i="1">
                 <a:solidFill>
                   <a:srgbClr val="4A526B"/>
                 </a:solidFill>
               </a:rPr>
-              <a:t>T3.2 Skill-gap mapping &amp; personas · T3.3 Assessment methodologies — from human-centric criteria to an interactive workshop toolkit</a:t>
+              <a:t>Co-designing human-centric pathways for future skills in manufacturing through augmented, empowered, inclusive and symbiotic complementarities between AI, automation and human tasks</a:t>
             </a:r>
           </a:p>
         </p:txBody>
@@ -7339,8 +7340,8 @@
         </p:nvSpPr>
         <p:spPr>
           <a:xfrm>
-            <a:off x="896112" y="1737360"/>
-            <a:ext cx="1170432" cy="1097280"/>
+            <a:off x="896112" y="1874519"/>
+            <a:ext cx="1984248" cy="960120"/>
           </a:xfrm>
           <a:prstGeom prst="roundRect">
             <a:avLst>
@@ -7383,8 +7384,8 @@
         </p:nvSpPr>
         <p:spPr>
           <a:xfrm>
-            <a:off x="896112" y="1764792"/>
-            <a:ext cx="1170432" cy="411480"/>
+            <a:off x="987552" y="1938528"/>
+            <a:ext cx="1801368" cy="411480"/>
           </a:xfrm>
           <a:prstGeom prst="rect">
             <a:avLst/>
@@ -7392,7 +7393,7 @@
           <a:noFill/>
         </p:spPr>
         <p:txBody>
-          <a:bodyPr wrap="square" lIns="0" rIns="0" tIns="0" bIns="0" anchor="t">
+          <a:bodyPr wrap="square" lIns="0" rIns="0" tIns="0" bIns="0" anchor="ctr">
             <a:spAutoFit/>
           </a:bodyPr>
           <a:lstStyle/>
@@ -7403,12 +7404,12 @@
               </a:spcAft>
             </a:pPr>
             <a:r>
-              <a:rPr sz="2100" b="1" i="0">
+              <a:rPr sz="1400" b="1" i="0">
                 <a:solidFill>
                   <a:srgbClr val="0092CA"/>
                 </a:solidFill>
               </a:rPr>
-              <a:t>5</a:t>
+              <a:t>Horizon Europe</a:t>
             </a:r>
           </a:p>
         </p:txBody>
@@ -7421,8 +7422,8 @@
         </p:nvSpPr>
         <p:spPr>
           <a:xfrm>
-            <a:off x="941832" y="2176272"/>
-            <a:ext cx="1078992" cy="329184"/>
+            <a:off x="987552" y="2340864"/>
+            <a:ext cx="1801368" cy="457200"/>
           </a:xfrm>
           <a:prstGeom prst="rect">
             <a:avLst/>
@@ -7441,64 +7442,26 @@
               </a:spcAft>
             </a:pPr>
             <a:r>
-              <a:rPr sz="800" b="1" i="0">
-                <a:solidFill>
-                  <a:srgbClr val="0B1138"/>
-                </a:solidFill>
-              </a:rPr>
-              <a:t>publications</a:t>
-            </a:r>
-          </a:p>
-        </p:txBody>
-      </p:sp>
-      <p:sp>
-        <p:nvSpPr>
-          <p:cNvPr id="8" name="TextBox 7"/>
-          <p:cNvSpPr txBox="1"/>
-          <p:nvPr/>
-        </p:nvSpPr>
-        <p:spPr>
-          <a:xfrm>
-            <a:off x="941832" y="2505456"/>
-            <a:ext cx="1078992" cy="310896"/>
-          </a:xfrm>
-          <a:prstGeom prst="rect">
-            <a:avLst/>
-          </a:prstGeom>
-          <a:noFill/>
-        </p:spPr>
-        <p:txBody>
-          <a:bodyPr wrap="square" lIns="0" rIns="0" tIns="0" bIns="0" anchor="t">
-            <a:spAutoFit/>
-          </a:bodyPr>
-          <a:lstStyle/>
-          <a:p>
-            <a:pPr algn="ctr">
-              <a:spcAft>
-                <a:spcPts val="0"/>
-              </a:spcAft>
-            </a:pPr>
-            <a:r>
-              <a:rPr sz="700" b="0" i="0">
+              <a:rPr sz="850" b="0" i="0">
                 <a:solidFill>
                   <a:srgbClr val="4A526B"/>
                 </a:solidFill>
               </a:rPr>
-              <a:t>IFAC · APMS · SPS ×2 · PLM</a:t>
-            </a:r>
-          </a:p>
-        </p:txBody>
-      </p:sp>
-      <p:sp>
-        <p:nvSpPr>
-          <p:cNvPr id="9" name="Rounded Rectangle 8"/>
+              <a:t>Grant Agreement 101177783 · co-funded by the Swiss SERI</a:t>
+            </a:r>
+          </a:p>
+        </p:txBody>
+      </p:sp>
+      <p:sp>
+        <p:nvSpPr>
+          <p:cNvPr id="8" name="Rounded Rectangle 7"/>
           <p:cNvSpPr/>
           <p:nvPr/>
         </p:nvSpPr>
         <p:spPr>
           <a:xfrm>
-            <a:off x="2139696" y="1737360"/>
-            <a:ext cx="1170432" cy="1097280"/>
+            <a:off x="2990088" y="1874519"/>
+            <a:ext cx="1984248" cy="960120"/>
           </a:xfrm>
           <a:prstGeom prst="roundRect">
             <a:avLst>
@@ -7535,14 +7498,14 @@
       </p:sp>
       <p:sp>
         <p:nvSpPr>
-          <p:cNvPr id="10" name="TextBox 9"/>
+          <p:cNvPr id="9" name="TextBox 8"/>
           <p:cNvSpPr txBox="1"/>
           <p:nvPr/>
         </p:nvSpPr>
         <p:spPr>
           <a:xfrm>
-            <a:off x="2139696" y="1764792"/>
-            <a:ext cx="1170432" cy="411480"/>
+            <a:off x="3081528" y="1938528"/>
+            <a:ext cx="1801368" cy="411480"/>
           </a:xfrm>
           <a:prstGeom prst="rect">
             <a:avLst/>
@@ -7550,7 +7513,7 @@
           <a:noFill/>
         </p:spPr>
         <p:txBody>
-          <a:bodyPr wrap="square" lIns="0" rIns="0" tIns="0" bIns="0" anchor="t">
+          <a:bodyPr wrap="square" lIns="0" rIns="0" tIns="0" bIns="0" anchor="ctr">
             <a:spAutoFit/>
           </a:bodyPr>
           <a:lstStyle/>
@@ -7561,26 +7524,26 @@
               </a:spcAft>
             </a:pPr>
             <a:r>
-              <a:rPr sz="2100" b="1" i="0">
+              <a:rPr sz="1400" b="1" i="0">
                 <a:solidFill>
                   <a:srgbClr val="0092CA"/>
                 </a:solidFill>
               </a:rPr>
-              <a:t>118</a:t>
-            </a:r>
-          </a:p>
-        </p:txBody>
-      </p:sp>
-      <p:sp>
-        <p:nvSpPr>
-          <p:cNvPr id="11" name="TextBox 10"/>
+              <a:t>36 months</a:t>
+            </a:r>
+          </a:p>
+        </p:txBody>
+      </p:sp>
+      <p:sp>
+        <p:nvSpPr>
+          <p:cNvPr id="10" name="TextBox 9"/>
           <p:cNvSpPr txBox="1"/>
           <p:nvPr/>
         </p:nvSpPr>
         <p:spPr>
           <a:xfrm>
-            <a:off x="2185415" y="2176272"/>
-            <a:ext cx="1078992" cy="329184"/>
+            <a:off x="3081528" y="2340864"/>
+            <a:ext cx="1801368" cy="457200"/>
           </a:xfrm>
           <a:prstGeom prst="rect">
             <a:avLst/>
@@ -7599,64 +7562,26 @@
               </a:spcAft>
             </a:pPr>
             <a:r>
-              <a:rPr sz="800" b="1" i="0">
-                <a:solidFill>
-                  <a:srgbClr val="0B1138"/>
-                </a:solidFill>
-              </a:rPr>
-              <a:t>workshop participants</a:t>
-            </a:r>
-          </a:p>
-        </p:txBody>
-      </p:sp>
-      <p:sp>
-        <p:nvSpPr>
-          <p:cNvPr id="12" name="TextBox 11"/>
-          <p:cNvSpPr txBox="1"/>
-          <p:nvPr/>
-        </p:nvSpPr>
-        <p:spPr>
-          <a:xfrm>
-            <a:off x="2185415" y="2505456"/>
-            <a:ext cx="1078992" cy="310896"/>
-          </a:xfrm>
-          <a:prstGeom prst="rect">
-            <a:avLst/>
-          </a:prstGeom>
-          <a:noFill/>
-        </p:spPr>
-        <p:txBody>
-          <a:bodyPr wrap="square" lIns="0" rIns="0" tIns="0" bIns="0" anchor="t">
-            <a:spAutoFit/>
-          </a:bodyPr>
-          <a:lstStyle/>
-          <a:p>
-            <a:pPr algn="ctr">
-              <a:spcAft>
-                <a:spcPts val="0"/>
-              </a:spcAft>
-            </a:pPr>
-            <a:r>
-              <a:rPr sz="700" b="0" i="0">
+              <a:rPr sz="850" b="0" i="0">
                 <a:solidFill>
                   <a:srgbClr val="4A526B"/>
                 </a:solidFill>
               </a:rPr>
-              <a:t>2 AIM co-creation events</a:t>
-            </a:r>
-          </a:p>
-        </p:txBody>
-      </p:sp>
-      <p:sp>
-        <p:nvSpPr>
-          <p:cNvPr id="13" name="Rounded Rectangle 12"/>
+              <a:t>1 Dec 2024 – 30 Nov 2027</a:t>
+            </a:r>
+          </a:p>
+        </p:txBody>
+      </p:sp>
+      <p:sp>
+        <p:nvSpPr>
+          <p:cNvPr id="11" name="Rounded Rectangle 10"/>
           <p:cNvSpPr/>
           <p:nvPr/>
         </p:nvSpPr>
         <p:spPr>
           <a:xfrm>
-            <a:off x="3383280" y="1737360"/>
-            <a:ext cx="1170432" cy="1097280"/>
+            <a:off x="5084064" y="1874519"/>
+            <a:ext cx="1984248" cy="960120"/>
           </a:xfrm>
           <a:prstGeom prst="roundRect">
             <a:avLst>
@@ -7693,14 +7618,14 @@
       </p:sp>
       <p:sp>
         <p:nvSpPr>
-          <p:cNvPr id="14" name="TextBox 13"/>
+          <p:cNvPr id="12" name="TextBox 11"/>
           <p:cNvSpPr txBox="1"/>
           <p:nvPr/>
         </p:nvSpPr>
         <p:spPr>
           <a:xfrm>
-            <a:off x="3383280" y="1764792"/>
-            <a:ext cx="1170432" cy="411480"/>
+            <a:off x="5175504" y="1938528"/>
+            <a:ext cx="1801368" cy="411480"/>
           </a:xfrm>
           <a:prstGeom prst="rect">
             <a:avLst/>
@@ -7708,7 +7633,7 @@
           <a:noFill/>
         </p:spPr>
         <p:txBody>
-          <a:bodyPr wrap="square" lIns="0" rIns="0" tIns="0" bIns="0" anchor="t">
+          <a:bodyPr wrap="square" lIns="0" rIns="0" tIns="0" bIns="0" anchor="ctr">
             <a:spAutoFit/>
           </a:bodyPr>
           <a:lstStyle/>
@@ -7719,26 +7644,26 @@
               </a:spcAft>
             </a:pPr>
             <a:r>
-              <a:rPr sz="2100" b="1" i="0">
+              <a:rPr sz="1400" b="1" i="0">
                 <a:solidFill>
                   <a:srgbClr val="0092CA"/>
                 </a:solidFill>
               </a:rPr>
-              <a:t>24</a:t>
-            </a:r>
-          </a:p>
-        </p:txBody>
-      </p:sp>
-      <p:sp>
-        <p:nvSpPr>
-          <p:cNvPr id="15" name="TextBox 14"/>
+              <a:t>€ 2.999 M</a:t>
+            </a:r>
+          </a:p>
+        </p:txBody>
+      </p:sp>
+      <p:sp>
+        <p:nvSpPr>
+          <p:cNvPr id="13" name="TextBox 12"/>
           <p:cNvSpPr txBox="1"/>
           <p:nvPr/>
         </p:nvSpPr>
         <p:spPr>
           <a:xfrm>
-            <a:off x="3429000" y="2176272"/>
-            <a:ext cx="1078992" cy="329184"/>
+            <a:off x="5175504" y="2340864"/>
+            <a:ext cx="1801368" cy="457200"/>
           </a:xfrm>
           <a:prstGeom prst="rect">
             <a:avLst/>
@@ -7757,64 +7682,26 @@
               </a:spcAft>
             </a:pPr>
             <a:r>
-              <a:rPr sz="800" b="1" i="0">
-                <a:solidFill>
-                  <a:srgbClr val="0B1138"/>
-                </a:solidFill>
-              </a:rPr>
-              <a:t>survey respondents</a:t>
-            </a:r>
-          </a:p>
-        </p:txBody>
-      </p:sp>
-      <p:sp>
-        <p:nvSpPr>
-          <p:cNvPr id="16" name="TextBox 15"/>
-          <p:cNvSpPr txBox="1"/>
-          <p:nvPr/>
-        </p:nvSpPr>
-        <p:spPr>
-          <a:xfrm>
-            <a:off x="3429000" y="2505456"/>
-            <a:ext cx="1078992" cy="310896"/>
-          </a:xfrm>
-          <a:prstGeom prst="rect">
-            <a:avLst/>
-          </a:prstGeom>
-          <a:noFill/>
-        </p:spPr>
-        <p:txBody>
-          <a:bodyPr wrap="square" lIns="0" rIns="0" tIns="0" bIns="0" anchor="t">
-            <a:spAutoFit/>
-          </a:bodyPr>
-          <a:lstStyle/>
-          <a:p>
-            <a:pPr algn="ctr">
-              <a:spcAft>
-                <a:spcPts val="0"/>
-              </a:spcAft>
-            </a:pPr>
-            <a:r>
-              <a:rPr sz="700" b="0" i="0">
+              <a:rPr sz="850" b="0" i="0">
                 <a:solidFill>
                   <a:srgbClr val="4A526B"/>
                 </a:solidFill>
               </a:rPr>
-              <a:t>managers &amp; experts</a:t>
-            </a:r>
-          </a:p>
-        </p:txBody>
-      </p:sp>
-      <p:sp>
-        <p:nvSpPr>
-          <p:cNvPr id="17" name="Rounded Rectangle 16"/>
+              <a:t>EU contribution</a:t>
+            </a:r>
+          </a:p>
+        </p:txBody>
+      </p:sp>
+      <p:sp>
+        <p:nvSpPr>
+          <p:cNvPr id="14" name="Rounded Rectangle 13"/>
           <p:cNvSpPr/>
           <p:nvPr/>
         </p:nvSpPr>
         <p:spPr>
           <a:xfrm>
-            <a:off x="4626864" y="1737360"/>
-            <a:ext cx="1170432" cy="1097280"/>
+            <a:off x="7178040" y="1874519"/>
+            <a:ext cx="1984248" cy="960120"/>
           </a:xfrm>
           <a:prstGeom prst="roundRect">
             <a:avLst>
@@ -7851,14 +7738,14 @@
       </p:sp>
       <p:sp>
         <p:nvSpPr>
-          <p:cNvPr id="18" name="TextBox 17"/>
+          <p:cNvPr id="15" name="TextBox 14"/>
           <p:cNvSpPr txBox="1"/>
           <p:nvPr/>
         </p:nvSpPr>
         <p:spPr>
           <a:xfrm>
-            <a:off x="4626864" y="1764792"/>
-            <a:ext cx="1170432" cy="411480"/>
+            <a:off x="7269479" y="1938528"/>
+            <a:ext cx="1801368" cy="411480"/>
           </a:xfrm>
           <a:prstGeom prst="rect">
             <a:avLst/>
@@ -7866,7 +7753,7 @@
           <a:noFill/>
         </p:spPr>
         <p:txBody>
-          <a:bodyPr wrap="square" lIns="0" rIns="0" tIns="0" bIns="0" anchor="t">
+          <a:bodyPr wrap="square" lIns="0" rIns="0" tIns="0" bIns="0" anchor="ctr">
             <a:spAutoFit/>
           </a:bodyPr>
           <a:lstStyle/>
@@ -7877,26 +7764,26 @@
               </a:spcAft>
             </a:pPr>
             <a:r>
-              <a:rPr sz="2100" b="1" i="0">
+              <a:rPr sz="1400" b="1" i="0">
                 <a:solidFill>
                   <a:srgbClr val="0092CA"/>
                 </a:solidFill>
               </a:rPr>
-              <a:t>10</a:t>
-            </a:r>
-          </a:p>
-        </p:txBody>
-      </p:sp>
-      <p:sp>
-        <p:nvSpPr>
-          <p:cNvPr id="19" name="TextBox 18"/>
+              <a:t>14 partners</a:t>
+            </a:r>
+          </a:p>
+        </p:txBody>
+      </p:sp>
+      <p:sp>
+        <p:nvSpPr>
+          <p:cNvPr id="16" name="TextBox 15"/>
           <p:cNvSpPr txBox="1"/>
           <p:nvPr/>
         </p:nvSpPr>
         <p:spPr>
           <a:xfrm>
-            <a:off x="4672584" y="2176272"/>
-            <a:ext cx="1078992" cy="329184"/>
+            <a:off x="7269479" y="2340864"/>
+            <a:ext cx="1801368" cy="457200"/>
           </a:xfrm>
           <a:prstGeom prst="rect">
             <a:avLst/>
@@ -7915,64 +7802,26 @@
               </a:spcAft>
             </a:pPr>
             <a:r>
-              <a:rPr sz="800" b="1" i="0">
-                <a:solidFill>
-                  <a:srgbClr val="0B1138"/>
-                </a:solidFill>
-              </a:rPr>
-              <a:t>operator interviews</a:t>
-            </a:r>
-          </a:p>
-        </p:txBody>
-      </p:sp>
-      <p:sp>
-        <p:nvSpPr>
-          <p:cNvPr id="20" name="TextBox 19"/>
-          <p:cNvSpPr txBox="1"/>
-          <p:nvPr/>
-        </p:nvSpPr>
-        <p:spPr>
-          <a:xfrm>
-            <a:off x="4672584" y="2505456"/>
-            <a:ext cx="1078992" cy="310896"/>
-          </a:xfrm>
-          <a:prstGeom prst="rect">
-            <a:avLst/>
-          </a:prstGeom>
-          <a:noFill/>
-        </p:spPr>
-        <p:txBody>
-          <a:bodyPr wrap="square" lIns="0" rIns="0" tIns="0" bIns="0" anchor="t">
-            <a:spAutoFit/>
-          </a:bodyPr>
-          <a:lstStyle/>
-          <a:p>
-            <a:pPr algn="ctr">
-              <a:spcAft>
-                <a:spcPts val="0"/>
-              </a:spcAft>
-            </a:pPr>
-            <a:r>
-              <a:rPr sz="700" b="0" i="0">
+              <a:rPr sz="850" b="0" i="0">
                 <a:solidFill>
                   <a:srgbClr val="4A526B"/>
                 </a:solidFill>
               </a:rPr>
-              <a:t>SSAB · System 3R · Natl. Gummi</a:t>
-            </a:r>
-          </a:p>
-        </p:txBody>
-      </p:sp>
-      <p:sp>
-        <p:nvSpPr>
-          <p:cNvPr id="21" name="Rounded Rectangle 20"/>
+              <a:t>across Europe · coordinator Politecnico di Milano</a:t>
+            </a:r>
+          </a:p>
+        </p:txBody>
+      </p:sp>
+      <p:sp>
+        <p:nvSpPr>
+          <p:cNvPr id="17" name="Rounded Rectangle 16"/>
           <p:cNvSpPr/>
           <p:nvPr/>
         </p:nvSpPr>
         <p:spPr>
           <a:xfrm>
-            <a:off x="896112" y="2971800"/>
-            <a:ext cx="4892040" cy="3200400"/>
+            <a:off x="9272016" y="1874519"/>
+            <a:ext cx="1984248" cy="960120"/>
           </a:xfrm>
           <a:prstGeom prst="roundRect">
             <a:avLst>
@@ -7980,7 +7829,7 @@
             </a:avLst>
           </a:prstGeom>
           <a:solidFill>
-            <a:srgbClr val="E3F6FD"/>
+            <a:srgbClr val="EEF1F6"/>
           </a:solidFill>
           <a:ln>
             <a:noFill/>
@@ -8009,14 +7858,14 @@
       </p:sp>
       <p:sp>
         <p:nvSpPr>
-          <p:cNvPr id="22" name="TextBox 21"/>
+          <p:cNvPr id="18" name="TextBox 17"/>
           <p:cNvSpPr txBox="1"/>
           <p:nvPr/>
         </p:nvSpPr>
         <p:spPr>
           <a:xfrm>
-            <a:off x="1078992" y="3063240"/>
-            <a:ext cx="4526279" cy="320040"/>
+            <a:off x="9363456" y="1938528"/>
+            <a:ext cx="1801368" cy="411480"/>
           </a:xfrm>
           <a:prstGeom prst="rect">
             <a:avLst/>
@@ -8024,37 +7873,37 @@
           <a:noFill/>
         </p:spPr>
         <p:txBody>
-          <a:bodyPr wrap="square" lIns="0" rIns="0" tIns="0" bIns="0" anchor="t">
+          <a:bodyPr wrap="square" lIns="0" rIns="0" tIns="0" bIns="0" anchor="ctr">
             <a:spAutoFit/>
           </a:bodyPr>
           <a:lstStyle/>
           <a:p>
-            <a:pPr algn="l">
+            <a:pPr algn="ctr">
               <a:spcAft>
                 <a:spcPts val="300"/>
               </a:spcAft>
             </a:pPr>
             <a:r>
-              <a:rPr sz="1250" b="1" i="0">
+              <a:rPr sz="1150" b="1" i="0">
                 <a:solidFill>
                   <a:srgbClr val="0092CA"/>
                 </a:solidFill>
               </a:rPr>
-              <a:t>Research results feeding D3.2</a:t>
-            </a:r>
-          </a:p>
-        </p:txBody>
-      </p:sp>
-      <p:sp>
-        <p:nvSpPr>
-          <p:cNvPr id="23" name="TextBox 22"/>
+              <a:t>15 Learning Factories</a:t>
+            </a:r>
+          </a:p>
+        </p:txBody>
+      </p:sp>
+      <p:sp>
+        <p:nvSpPr>
+          <p:cNvPr id="19" name="TextBox 18"/>
           <p:cNvSpPr txBox="1"/>
           <p:nvPr/>
         </p:nvSpPr>
         <p:spPr>
           <a:xfrm>
-            <a:off x="1078992" y="3429000"/>
-            <a:ext cx="4526279" cy="2697480"/>
+            <a:off x="9363456" y="2340864"/>
+            <a:ext cx="1801368" cy="457200"/>
           </a:xfrm>
           <a:prstGeom prst="rect">
             <a:avLst/>
@@ -8067,174 +7916,43 @@
           </a:bodyPr>
           <a:lstStyle/>
           <a:p>
-            <a:pPr algn="l" marL="164592" indent="-164592">
+            <a:pPr algn="ctr">
               <a:spcAft>
-                <a:spcPts val="400"/>
+                <a:spcPts val="0"/>
               </a:spcAft>
-              <a:buChar char="•"/>
             </a:pPr>
             <a:r>
-              <a:rPr sz="950" b="1" i="0">
+              <a:rPr sz="850" b="0" i="0">
                 <a:solidFill>
-                  <a:srgbClr val="0B1138"/>
+                  <a:srgbClr val="4A526B"/>
                 </a:solidFill>
               </a:rPr>
-              <a:t>Worker-demand taxonomy</a:t>
-            </a:r>
-            <a:r>
-              <a:rPr sz="950" b="0" i="0">
-                <a:solidFill>
-                  <a:srgbClr val="0B1138"/>
-                </a:solidFill>
-              </a:rPr>
-              <a:t> – core (physical / cognitive / sensing) and contextual demands (leadership, training, social inclusion) · SPS 2026</a:t>
-            </a:r>
-          </a:p>
-          <a:p>
-            <a:pPr algn="l" marL="164592" indent="-164592">
-              <a:spcAft>
-                <a:spcPts val="400"/>
-              </a:spcAft>
-              <a:buChar char="•"/>
-            </a:pPr>
-            <a:r>
-              <a:rPr sz="950" b="1" i="0">
-                <a:solidFill>
-                  <a:srgbClr val="0B1138"/>
-                </a:solidFill>
-              </a:rPr>
-              <a:t>Human–AI collaboration principles</a:t>
-            </a:r>
-            <a:r>
-              <a:rPr sz="950" b="0" i="0">
-                <a:solidFill>
-                  <a:srgbClr val="0B1138"/>
-                </a:solidFill>
-              </a:rPr>
-              <a:t> – trust, autonomy, usability for shared tasks · APMS 2026</a:t>
-            </a:r>
-          </a:p>
-          <a:p>
-            <a:pPr algn="l" marL="164592" indent="-164592">
-              <a:spcAft>
-                <a:spcPts val="400"/>
-              </a:spcAft>
-              <a:buChar char="•"/>
-            </a:pPr>
-            <a:r>
-              <a:rPr sz="950" b="1" i="0">
-                <a:solidFill>
-                  <a:srgbClr val="0B1138"/>
-                </a:solidFill>
-              </a:rPr>
-              <a:t>Five vulnerable-group personas</a:t>
-            </a:r>
-            <a:r>
-              <a:rPr sz="950" b="0" i="0">
-                <a:solidFill>
-                  <a:srgbClr val="0B1138"/>
-                </a:solidFill>
-              </a:rPr>
-              <a:t> + multimodal-redundancy design principle · PLM 2026</a:t>
-            </a:r>
-          </a:p>
-          <a:p>
-            <a:pPr algn="l" marL="164592" indent="-164592">
-              <a:spcAft>
-                <a:spcPts val="400"/>
-              </a:spcAft>
-              <a:buChar char="•"/>
-            </a:pPr>
-            <a:r>
-              <a:rPr sz="950" b="1" i="0">
-                <a:solidFill>
-                  <a:srgbClr val="0B1138"/>
-                </a:solidFill>
-              </a:rPr>
-              <a:t>Operator evidence</a:t>
-            </a:r>
-            <a:r>
-              <a:rPr sz="950" b="0" i="0">
-                <a:solidFill>
-                  <a:srgbClr val="0B1138"/>
-                </a:solidFill>
-              </a:rPr>
-              <a:t> – 10 interviews → 6 human-centric factors, 5 implementation principles (involvement, transparency, social learning, learning by doing, continuous governance)</a:t>
-            </a:r>
-          </a:p>
-          <a:p>
-            <a:pPr algn="l" marL="164592" indent="-164592">
-              <a:spcAft>
-                <a:spcPts val="400"/>
-              </a:spcAft>
-              <a:buChar char="•"/>
-            </a:pPr>
-            <a:r>
-              <a:rPr sz="950" b="1" i="0">
-                <a:solidFill>
-                  <a:srgbClr val="0B1138"/>
-                </a:solidFill>
-              </a:rPr>
-              <a:t>Actionable requirement lists</a:t>
-            </a:r>
-            <a:r>
-              <a:rPr sz="950" b="0" i="0">
-                <a:solidFill>
-                  <a:srgbClr val="0B1138"/>
-                </a:solidFill>
-              </a:rPr>
-              <a:t> – Task characteristics TA1–9, Technology requirements TE1–16, Organisational conditions OR1–10, mapped per worker group × learning pathway</a:t>
-            </a:r>
-          </a:p>
-          <a:p>
-            <a:pPr algn="l" marL="164592" indent="-164592">
-              <a:spcAft>
-                <a:spcPts val="400"/>
-              </a:spcAft>
-              <a:buChar char="•"/>
-            </a:pPr>
-            <a:r>
-              <a:rPr sz="950" b="1" i="0">
-                <a:solidFill>
-                  <a:srgbClr val="0B1138"/>
-                </a:solidFill>
-              </a:rPr>
-              <a:t>Assessment building blocks</a:t>
-            </a:r>
-            <a:r>
-              <a:rPr sz="950" b="0" i="0">
-                <a:solidFill>
-                  <a:srgbClr val="0B1138"/>
-                </a:solidFill>
-              </a:rPr>
-              <a:t> – user journeys, goals &amp; metrics, micro → macro KPIs, human value–technology fit</a:t>
-            </a:r>
-          </a:p>
-        </p:txBody>
-      </p:sp>
-      <p:sp>
-        <p:nvSpPr>
-          <p:cNvPr id="24" name="Rounded Rectangle 23"/>
+              <a:t>3 per testbed – realistic training environments</a:t>
+            </a:r>
+          </a:p>
+        </p:txBody>
+      </p:sp>
+      <p:sp>
+        <p:nvSpPr>
+          <p:cNvPr id="20" name="Rounded Rectangle 19"/>
           <p:cNvSpPr/>
           <p:nvPr/>
         </p:nvSpPr>
         <p:spPr>
           <a:xfrm>
-            <a:off x="5989320" y="1737360"/>
-            <a:ext cx="5257800" cy="4434840"/>
+            <a:off x="896112" y="3017520"/>
+            <a:ext cx="4892040" cy="3154680"/>
           </a:xfrm>
           <a:prstGeom prst="roundRect">
             <a:avLst>
-              <a:gd name="adj" fmla="val 5000"/>
+              <a:gd name="adj" fmla="val 8000"/>
             </a:avLst>
           </a:prstGeom>
           <a:solidFill>
-            <a:srgbClr val="FFFFFF"/>
+            <a:srgbClr val="E3F6FD"/>
           </a:solidFill>
-          <a:ln w="25400">
-            <a:solidFill>
-              <a:srgbClr val="09BDF0"/>
-            </a:solidFill>
+          <a:ln>
+            <a:noFill/>
           </a:ln>
           <a:effectLst/>
         </p:spPr>
@@ -8260,25 +7978,210 @@
       </p:sp>
       <p:sp>
         <p:nvSpPr>
-          <p:cNvPr id="25" name="Rounded Rectangle 24"/>
+          <p:cNvPr id="21" name="TextBox 20"/>
+          <p:cNvSpPr txBox="1"/>
+          <p:nvPr/>
+        </p:nvSpPr>
+        <p:spPr>
+          <a:xfrm>
+            <a:off x="1078992" y="3108960"/>
+            <a:ext cx="4526280" cy="320040"/>
+          </a:xfrm>
+          <a:prstGeom prst="rect">
+            <a:avLst/>
+          </a:prstGeom>
+          <a:noFill/>
+        </p:spPr>
+        <p:txBody>
+          <a:bodyPr wrap="square" lIns="0" rIns="0" tIns="0" bIns="0" anchor="t">
+            <a:spAutoFit/>
+          </a:bodyPr>
+          <a:lstStyle/>
+          <a:p>
+            <a:pPr algn="l">
+              <a:spcAft>
+                <a:spcPts val="300"/>
+              </a:spcAft>
+            </a:pPr>
+            <a:r>
+              <a:rPr sz="1250" b="1" i="0">
+                <a:solidFill>
+                  <a:srgbClr val="0092CA"/>
+                </a:solidFill>
+              </a:rPr>
+              <a:t>Mission</a:t>
+            </a:r>
+          </a:p>
+        </p:txBody>
+      </p:sp>
+      <p:sp>
+        <p:nvSpPr>
+          <p:cNvPr id="22" name="TextBox 21"/>
+          <p:cNvSpPr txBox="1"/>
+          <p:nvPr/>
+        </p:nvSpPr>
+        <p:spPr>
+          <a:xfrm>
+            <a:off x="1078992" y="3456432"/>
+            <a:ext cx="4526280" cy="2651760"/>
+          </a:xfrm>
+          <a:prstGeom prst="rect">
+            <a:avLst/>
+          </a:prstGeom>
+          <a:noFill/>
+        </p:spPr>
+        <p:txBody>
+          <a:bodyPr wrap="square" lIns="0" rIns="0" tIns="0" bIns="0" anchor="t">
+            <a:spAutoFit/>
+          </a:bodyPr>
+          <a:lstStyle/>
+          <a:p>
+            <a:pPr algn="l">
+              <a:spcAft>
+                <a:spcPts val="500"/>
+              </a:spcAft>
+            </a:pPr>
+            <a:r>
+              <a:rPr sz="950" b="0" i="0">
+                <a:solidFill>
+                  <a:srgbClr val="0B1138"/>
+                </a:solidFill>
+              </a:rPr>
+              <a:t>AI and automation are reshaping manufacturing work. SkillAIbility keeps the worker at the centre: it develops criteria, models and tools so that AI complements human skills instead of displacing them – in line with Industry 5.0.</a:t>
+            </a:r>
+          </a:p>
+          <a:p>
+            <a:pPr algn="l">
+              <a:spcAft>
+                <a:spcPts val="500"/>
+              </a:spcAft>
+            </a:pPr>
+            <a:r>
+              <a:rPr sz="950" b="1" i="0">
+                <a:solidFill>
+                  <a:srgbClr val="0B1138"/>
+                </a:solidFill>
+              </a:rPr>
+              <a:t>Target groups: </a:t>
+            </a:r>
+            <a:r>
+              <a:rPr sz="950" b="0" i="0">
+                <a:solidFill>
+                  <a:srgbClr val="0B1138"/>
+                </a:solidFill>
+              </a:rPr>
+              <a:t>manufacturing workers, ageing personnel and vulnerable groups, with a specific focus on the deaf community and on people with cognitive or physical support needs.</a:t>
+            </a:r>
+          </a:p>
+          <a:p>
+            <a:pPr algn="l">
+              <a:spcAft>
+                <a:spcPts val="500"/>
+              </a:spcAft>
+            </a:pPr>
+            <a:r>
+              <a:rPr sz="950" b="1" i="0">
+                <a:solidFill>
+                  <a:srgbClr val="0B1138"/>
+                </a:solidFill>
+              </a:rPr>
+              <a:t>Expected outcomes: </a:t>
+            </a:r>
+            <a:r>
+              <a:rPr sz="950" b="0" i="0">
+                <a:solidFill>
+                  <a:srgbClr val="0B1138"/>
+                </a:solidFill>
+              </a:rPr>
+              <a:t>human-centric assessment criteria and personas, four upskilling pathways, validated proofs of concept in Learning Factories, higher employability of vulnerable and aged workers, and regulatory sandboxes for human-centric AI.</a:t>
+            </a:r>
+          </a:p>
+          <a:p>
+            <a:pPr algn="l">
+              <a:spcAft>
+                <a:spcPts val="500"/>
+              </a:spcAft>
+            </a:pPr>
+            <a:r>
+              <a:rPr sz="950" b="1" i="0">
+                <a:solidFill>
+                  <a:srgbClr val="0B1138"/>
+                </a:solidFill>
+              </a:rPr>
+              <a:t>WP3 – Human-centric criteria, modelling &amp; assessment: </a:t>
+            </a:r>
+            <a:r>
+              <a:rPr sz="950" b="0" i="0">
+                <a:solidFill>
+                  <a:srgbClr val="0B1138"/>
+                </a:solidFill>
+              </a:rPr>
+              <a:t>Chalmers leads T3.2 (skill-gap mapping &amp; personas) and T3.3 (assessment methodologies).</a:t>
+            </a:r>
+          </a:p>
+        </p:txBody>
+      </p:sp>
+      <p:sp>
+        <p:nvSpPr>
+          <p:cNvPr id="23" name="TextBox 22"/>
+          <p:cNvSpPr txBox="1"/>
+          <p:nvPr/>
+        </p:nvSpPr>
+        <p:spPr>
+          <a:xfrm>
+            <a:off x="5989320" y="3017520"/>
+            <a:ext cx="5257800" cy="320040"/>
+          </a:xfrm>
+          <a:prstGeom prst="rect">
+            <a:avLst/>
+          </a:prstGeom>
+          <a:noFill/>
+        </p:spPr>
+        <p:txBody>
+          <a:bodyPr wrap="square" lIns="0" rIns="0" tIns="0" bIns="0" anchor="t">
+            <a:spAutoFit/>
+          </a:bodyPr>
+          <a:lstStyle/>
+          <a:p>
+            <a:pPr algn="l">
+              <a:spcAft>
+                <a:spcPts val="300"/>
+              </a:spcAft>
+            </a:pPr>
+            <a:r>
+              <a:rPr sz="1250" b="1" i="0">
+                <a:solidFill>
+                  <a:srgbClr val="0092CA"/>
+                </a:solidFill>
+              </a:rPr>
+              <a:t>Four upskilling pathways</a:t>
+            </a:r>
+          </a:p>
+        </p:txBody>
+      </p:sp>
+      <p:sp>
+        <p:nvSpPr>
+          <p:cNvPr id="24" name="Rounded Rectangle 23"/>
           <p:cNvSpPr/>
           <p:nvPr/>
         </p:nvSpPr>
         <p:spPr>
           <a:xfrm>
-            <a:off x="6172200" y="1572768"/>
-            <a:ext cx="2194560" cy="329184"/>
+            <a:off x="5989320" y="3383280"/>
+            <a:ext cx="2587752" cy="1298448"/>
           </a:xfrm>
           <a:prstGeom prst="roundRect">
             <a:avLst>
-              <a:gd name="adj" fmla="val 50000"/>
+              <a:gd name="adj" fmla="val 6000"/>
             </a:avLst>
           </a:prstGeom>
           <a:solidFill>
-            <a:srgbClr val="09BDF0"/>
+            <a:srgbClr val="FFFFFF"/>
           </a:solidFill>
-          <a:ln>
-            <a:noFill/>
+          <a:ln w="25400">
+            <a:solidFill>
+              <a:srgbClr val="09BDF0"/>
+            </a:solidFill>
           </a:ln>
           <a:effectLst/>
         </p:spPr>
@@ -8304,52 +8207,14 @@
       </p:sp>
       <p:sp>
         <p:nvSpPr>
-          <p:cNvPr id="26" name="TextBox 25"/>
+          <p:cNvPr id="25" name="TextBox 24"/>
           <p:cNvSpPr txBox="1"/>
           <p:nvPr/>
         </p:nvSpPr>
         <p:spPr>
           <a:xfrm>
-            <a:off x="6172200" y="1572768"/>
-            <a:ext cx="2194560" cy="329184"/>
-          </a:xfrm>
-          <a:prstGeom prst="rect">
-            <a:avLst/>
-          </a:prstGeom>
-          <a:noFill/>
-        </p:spPr>
-        <p:txBody>
-          <a:bodyPr wrap="square" lIns="0" rIns="0" tIns="0" bIns="0" anchor="ctr">
-            <a:spAutoFit/>
-          </a:bodyPr>
-          <a:lstStyle/>
-          <a:p>
-            <a:pPr algn="ctr">
-              <a:spcAft>
-                <a:spcPts val="300"/>
-              </a:spcAft>
-            </a:pPr>
-            <a:r>
-              <a:rPr sz="1000" b="1" i="0">
-                <a:solidFill>
-                  <a:srgbClr val="0B1138"/>
-                </a:solidFill>
-              </a:rPr>
-              <a:t>MAIN OUTCOME</a:t>
-            </a:r>
-          </a:p>
-        </p:txBody>
-      </p:sp>
-      <p:sp>
-        <p:nvSpPr>
-          <p:cNvPr id="27" name="TextBox 26"/>
-          <p:cNvSpPr txBox="1"/>
-          <p:nvPr/>
-        </p:nvSpPr>
-        <p:spPr>
-          <a:xfrm>
-            <a:off x="6217920" y="1993392"/>
-            <a:ext cx="4800600" cy="411480"/>
+            <a:off x="6126480" y="3474720"/>
+            <a:ext cx="2331720" cy="320040"/>
           </a:xfrm>
           <a:prstGeom prst="rect">
             <a:avLst/>
@@ -8368,26 +8233,26 @@
               </a:spcAft>
             </a:pPr>
             <a:r>
-              <a:rPr sz="1800" b="1" i="0">
+              <a:rPr sz="1200" b="1" i="0">
                 <a:solidFill>
                   <a:srgbClr val="0B1138"/>
                 </a:solidFill>
               </a:rPr>
-              <a:t>Interactive Workshop Toolkit</a:t>
-            </a:r>
-          </a:p>
-        </p:txBody>
-      </p:sp>
-      <p:sp>
-        <p:nvSpPr>
-          <p:cNvPr id="28" name="TextBox 27"/>
+              <a:t>Augmentation</a:t>
+            </a:r>
+          </a:p>
+        </p:txBody>
+      </p:sp>
+      <p:sp>
+        <p:nvSpPr>
+          <p:cNvPr id="26" name="TextBox 25"/>
           <p:cNvSpPr txBox="1"/>
           <p:nvPr/>
         </p:nvSpPr>
         <p:spPr>
           <a:xfrm>
-            <a:off x="6217920" y="2395728"/>
-            <a:ext cx="4800600" cy="320040"/>
+            <a:off x="6126480" y="3794760"/>
+            <a:ext cx="2331720" cy="868680"/>
           </a:xfrm>
           <a:prstGeom prst="rect">
             <a:avLst/>
@@ -8406,37 +8271,39 @@
               </a:spcAft>
             </a:pPr>
             <a:r>
-              <a:rPr sz="1000" b="0" i="1">
+              <a:rPr sz="900" b="0" i="0">
                 <a:solidFill>
-                  <a:srgbClr val="4A526B"/>
+                  <a:srgbClr val="0B1138"/>
                 </a:solidFill>
               </a:rPr>
-              <a:t>Turns the WP3 models into a browser-based, data-collecting workshop – no login, no install.</a:t>
-            </a:r>
-          </a:p>
-        </p:txBody>
-      </p:sp>
-      <p:sp>
-        <p:nvSpPr>
-          <p:cNvPr id="29" name="Rounded Rectangle 28"/>
+              <a:t>Technology extends what a worker can do – better, faster, safer – while the human stays in charge.</a:t>
+            </a:r>
+          </a:p>
+        </p:txBody>
+      </p:sp>
+      <p:sp>
+        <p:nvSpPr>
+          <p:cNvPr id="27" name="Rounded Rectangle 26"/>
           <p:cNvSpPr/>
           <p:nvPr/>
         </p:nvSpPr>
         <p:spPr>
           <a:xfrm>
-            <a:off x="6172200" y="2743200"/>
-            <a:ext cx="2606040" cy="1719072"/>
+            <a:off x="8659367" y="3383280"/>
+            <a:ext cx="2587752" cy="1298448"/>
           </a:xfrm>
           <a:prstGeom prst="roundRect">
             <a:avLst>
-              <a:gd name="adj" fmla="val 8000"/>
+              <a:gd name="adj" fmla="val 6000"/>
             </a:avLst>
           </a:prstGeom>
           <a:solidFill>
-            <a:srgbClr val="D8DEE8"/>
+            <a:srgbClr val="FFFFFF"/>
           </a:solidFill>
-          <a:ln>
-            <a:noFill/>
+          <a:ln w="25400">
+            <a:solidFill>
+              <a:srgbClr val="09BDF0"/>
+            </a:solidFill>
           </a:ln>
           <a:effectLst/>
         </p:spPr>
@@ -8460,6 +8327,1622 @@
           <a:p/>
         </p:txBody>
       </p:sp>
+      <p:sp>
+        <p:nvSpPr>
+          <p:cNvPr id="28" name="TextBox 27"/>
+          <p:cNvSpPr txBox="1"/>
+          <p:nvPr/>
+        </p:nvSpPr>
+        <p:spPr>
+          <a:xfrm>
+            <a:off x="8796528" y="3474720"/>
+            <a:ext cx="2331720" cy="320040"/>
+          </a:xfrm>
+          <a:prstGeom prst="rect">
+            <a:avLst/>
+          </a:prstGeom>
+          <a:noFill/>
+        </p:spPr>
+        <p:txBody>
+          <a:bodyPr wrap="square" lIns="0" rIns="0" tIns="0" bIns="0" anchor="t">
+            <a:spAutoFit/>
+          </a:bodyPr>
+          <a:lstStyle/>
+          <a:p>
+            <a:pPr algn="l">
+              <a:spcAft>
+                <a:spcPts val="300"/>
+              </a:spcAft>
+            </a:pPr>
+            <a:r>
+              <a:rPr sz="1200" b="1" i="0">
+                <a:solidFill>
+                  <a:srgbClr val="0B1138"/>
+                </a:solidFill>
+              </a:rPr>
+              <a:t>Inclusion</a:t>
+            </a:r>
+          </a:p>
+        </p:txBody>
+      </p:sp>
+      <p:sp>
+        <p:nvSpPr>
+          <p:cNvPr id="29" name="TextBox 28"/>
+          <p:cNvSpPr txBox="1"/>
+          <p:nvPr/>
+        </p:nvSpPr>
+        <p:spPr>
+          <a:xfrm>
+            <a:off x="8796528" y="3794760"/>
+            <a:ext cx="2331720" cy="868680"/>
+          </a:xfrm>
+          <a:prstGeom prst="rect">
+            <a:avLst/>
+          </a:prstGeom>
+          <a:noFill/>
+        </p:spPr>
+        <p:txBody>
+          <a:bodyPr wrap="square" lIns="0" rIns="0" tIns="0" bIns="0" anchor="t">
+            <a:spAutoFit/>
+          </a:bodyPr>
+          <a:lstStyle/>
+          <a:p>
+            <a:pPr algn="l">
+              <a:spcAft>
+                <a:spcPts val="300"/>
+              </a:spcAft>
+            </a:pPr>
+            <a:r>
+              <a:rPr sz="900" b="0" i="0">
+                <a:solidFill>
+                  <a:srgbClr val="0B1138"/>
+                </a:solidFill>
+              </a:rPr>
+              <a:t>Barriers are removed so that vulnerable and disabled workers can perform the task and take part on equal terms.</a:t>
+            </a:r>
+          </a:p>
+        </p:txBody>
+      </p:sp>
+      <p:sp>
+        <p:nvSpPr>
+          <p:cNvPr id="30" name="Rounded Rectangle 29"/>
+          <p:cNvSpPr/>
+          <p:nvPr/>
+        </p:nvSpPr>
+        <p:spPr>
+          <a:xfrm>
+            <a:off x="5989320" y="4800600"/>
+            <a:ext cx="2587752" cy="1298448"/>
+          </a:xfrm>
+          <a:prstGeom prst="roundRect">
+            <a:avLst>
+              <a:gd name="adj" fmla="val 6000"/>
+            </a:avLst>
+          </a:prstGeom>
+          <a:solidFill>
+            <a:srgbClr val="FFFFFF"/>
+          </a:solidFill>
+          <a:ln w="25400">
+            <a:solidFill>
+              <a:srgbClr val="09BDF0"/>
+            </a:solidFill>
+          </a:ln>
+          <a:effectLst/>
+        </p:spPr>
+        <p:style>
+          <a:lnRef idx="1">
+            <a:schemeClr val="accent1"/>
+          </a:lnRef>
+          <a:fillRef idx="3">
+            <a:schemeClr val="accent1"/>
+          </a:fillRef>
+          <a:effectRef idx="2">
+            <a:schemeClr val="accent1"/>
+          </a:effectRef>
+          <a:fontRef idx="minor">
+            <a:schemeClr val="lt1"/>
+          </a:fontRef>
+        </p:style>
+        <p:txBody>
+          <a:bodyPr rtlCol="0" anchor="ctr"/>
+          <a:lstStyle/>
+          <a:p/>
+        </p:txBody>
+      </p:sp>
+      <p:sp>
+        <p:nvSpPr>
+          <p:cNvPr id="31" name="TextBox 30"/>
+          <p:cNvSpPr txBox="1"/>
+          <p:nvPr/>
+        </p:nvSpPr>
+        <p:spPr>
+          <a:xfrm>
+            <a:off x="6126480" y="4892040"/>
+            <a:ext cx="2331720" cy="320040"/>
+          </a:xfrm>
+          <a:prstGeom prst="rect">
+            <a:avLst/>
+          </a:prstGeom>
+          <a:noFill/>
+        </p:spPr>
+        <p:txBody>
+          <a:bodyPr wrap="square" lIns="0" rIns="0" tIns="0" bIns="0" anchor="t">
+            <a:spAutoFit/>
+          </a:bodyPr>
+          <a:lstStyle/>
+          <a:p>
+            <a:pPr algn="l">
+              <a:spcAft>
+                <a:spcPts val="300"/>
+              </a:spcAft>
+            </a:pPr>
+            <a:r>
+              <a:rPr sz="1200" b="1" i="0">
+                <a:solidFill>
+                  <a:srgbClr val="0B1138"/>
+                </a:solidFill>
+              </a:rPr>
+              <a:t>Symbiosis</a:t>
+            </a:r>
+          </a:p>
+        </p:txBody>
+      </p:sp>
+      <p:sp>
+        <p:nvSpPr>
+          <p:cNvPr id="32" name="TextBox 31"/>
+          <p:cNvSpPr txBox="1"/>
+          <p:nvPr/>
+        </p:nvSpPr>
+        <p:spPr>
+          <a:xfrm>
+            <a:off x="6126480" y="5212080"/>
+            <a:ext cx="2331720" cy="868680"/>
+          </a:xfrm>
+          <a:prstGeom prst="rect">
+            <a:avLst/>
+          </a:prstGeom>
+          <a:noFill/>
+        </p:spPr>
+        <p:txBody>
+          <a:bodyPr wrap="square" lIns="0" rIns="0" tIns="0" bIns="0" anchor="t">
+            <a:spAutoFit/>
+          </a:bodyPr>
+          <a:lstStyle/>
+          <a:p>
+            <a:pPr algn="l">
+              <a:spcAft>
+                <a:spcPts val="300"/>
+              </a:spcAft>
+            </a:pPr>
+            <a:r>
+              <a:rPr sz="900" b="0" i="0">
+                <a:solidFill>
+                  <a:srgbClr val="0B1138"/>
+                </a:solidFill>
+              </a:rPr>
+              <a:t>Human and AI work as one system – tasks shared and adapted, with two-way communication and trust.</a:t>
+            </a:r>
+          </a:p>
+        </p:txBody>
+      </p:sp>
+      <p:sp>
+        <p:nvSpPr>
+          <p:cNvPr id="33" name="Rounded Rectangle 32"/>
+          <p:cNvSpPr/>
+          <p:nvPr/>
+        </p:nvSpPr>
+        <p:spPr>
+          <a:xfrm>
+            <a:off x="8659367" y="4800600"/>
+            <a:ext cx="2587752" cy="1298448"/>
+          </a:xfrm>
+          <a:prstGeom prst="roundRect">
+            <a:avLst>
+              <a:gd name="adj" fmla="val 6000"/>
+            </a:avLst>
+          </a:prstGeom>
+          <a:solidFill>
+            <a:srgbClr val="FFFFFF"/>
+          </a:solidFill>
+          <a:ln w="25400">
+            <a:solidFill>
+              <a:srgbClr val="09BDF0"/>
+            </a:solidFill>
+          </a:ln>
+          <a:effectLst/>
+        </p:spPr>
+        <p:style>
+          <a:lnRef idx="1">
+            <a:schemeClr val="accent1"/>
+          </a:lnRef>
+          <a:fillRef idx="3">
+            <a:schemeClr val="accent1"/>
+          </a:fillRef>
+          <a:effectRef idx="2">
+            <a:schemeClr val="accent1"/>
+          </a:effectRef>
+          <a:fontRef idx="minor">
+            <a:schemeClr val="lt1"/>
+          </a:fontRef>
+        </p:style>
+        <p:txBody>
+          <a:bodyPr rtlCol="0" anchor="ctr"/>
+          <a:lstStyle/>
+          <a:p/>
+        </p:txBody>
+      </p:sp>
+      <p:sp>
+        <p:nvSpPr>
+          <p:cNvPr id="34" name="TextBox 33"/>
+          <p:cNvSpPr txBox="1"/>
+          <p:nvPr/>
+        </p:nvSpPr>
+        <p:spPr>
+          <a:xfrm>
+            <a:off x="8796528" y="4892040"/>
+            <a:ext cx="2331720" cy="320040"/>
+          </a:xfrm>
+          <a:prstGeom prst="rect">
+            <a:avLst/>
+          </a:prstGeom>
+          <a:noFill/>
+        </p:spPr>
+        <p:txBody>
+          <a:bodyPr wrap="square" lIns="0" rIns="0" tIns="0" bIns="0" anchor="t">
+            <a:spAutoFit/>
+          </a:bodyPr>
+          <a:lstStyle/>
+          <a:p>
+            <a:pPr algn="l">
+              <a:spcAft>
+                <a:spcPts val="300"/>
+              </a:spcAft>
+            </a:pPr>
+            <a:r>
+              <a:rPr sz="1200" b="1" i="0">
+                <a:solidFill>
+                  <a:srgbClr val="0B1138"/>
+                </a:solidFill>
+              </a:rPr>
+              <a:t>Empowerment</a:t>
+            </a:r>
+          </a:p>
+        </p:txBody>
+      </p:sp>
+      <p:sp>
+        <p:nvSpPr>
+          <p:cNvPr id="35" name="TextBox 34"/>
+          <p:cNvSpPr txBox="1"/>
+          <p:nvPr/>
+        </p:nvSpPr>
+        <p:spPr>
+          <a:xfrm>
+            <a:off x="8796528" y="5212080"/>
+            <a:ext cx="2331720" cy="868680"/>
+          </a:xfrm>
+          <a:prstGeom prst="rect">
+            <a:avLst/>
+          </a:prstGeom>
+          <a:noFill/>
+        </p:spPr>
+        <p:txBody>
+          <a:bodyPr wrap="square" lIns="0" rIns="0" tIns="0" bIns="0" anchor="t">
+            <a:spAutoFit/>
+          </a:bodyPr>
+          <a:lstStyle/>
+          <a:p>
+            <a:pPr algn="l">
+              <a:spcAft>
+                <a:spcPts val="300"/>
+              </a:spcAft>
+            </a:pPr>
+            <a:r>
+              <a:rPr sz="900" b="0" i="0">
+                <a:solidFill>
+                  <a:srgbClr val="0B1138"/>
+                </a:solidFill>
+              </a:rPr>
+              <a:t>Workers grow and decide: skills, autonomy, confidence and a say in shaping the technology.</a:t>
+            </a:r>
+          </a:p>
+        </p:txBody>
+      </p:sp>
+      <p:sp>
+        <p:nvSpPr>
+          <p:cNvPr id="36" name="Rounded Rectangle 35"/>
+          <p:cNvSpPr/>
+          <p:nvPr/>
+        </p:nvSpPr>
+        <p:spPr>
+          <a:xfrm>
+            <a:off x="896112" y="6263640"/>
+            <a:ext cx="10351008" cy="301752"/>
+          </a:xfrm>
+          <a:prstGeom prst="roundRect">
+            <a:avLst>
+              <a:gd name="adj" fmla="val 30000"/>
+            </a:avLst>
+          </a:prstGeom>
+          <a:solidFill>
+            <a:srgbClr val="0B1138"/>
+          </a:solidFill>
+          <a:ln>
+            <a:noFill/>
+          </a:ln>
+          <a:effectLst/>
+        </p:spPr>
+        <p:style>
+          <a:lnRef idx="1">
+            <a:schemeClr val="accent1"/>
+          </a:lnRef>
+          <a:fillRef idx="3">
+            <a:schemeClr val="accent1"/>
+          </a:fillRef>
+          <a:effectRef idx="2">
+            <a:schemeClr val="accent1"/>
+          </a:effectRef>
+          <a:fontRef idx="minor">
+            <a:schemeClr val="lt1"/>
+          </a:fontRef>
+        </p:style>
+        <p:txBody>
+          <a:bodyPr rtlCol="0" anchor="ctr"/>
+          <a:lstStyle/>
+          <a:p/>
+        </p:txBody>
+      </p:sp>
+      <p:sp>
+        <p:nvSpPr>
+          <p:cNvPr id="37" name="TextBox 36"/>
+          <p:cNvSpPr txBox="1"/>
+          <p:nvPr/>
+        </p:nvSpPr>
+        <p:spPr>
+          <a:xfrm>
+            <a:off x="1097280" y="6263640"/>
+            <a:ext cx="9966960" cy="301752"/>
+          </a:xfrm>
+          <a:prstGeom prst="rect">
+            <a:avLst/>
+          </a:prstGeom>
+          <a:noFill/>
+        </p:spPr>
+        <p:txBody>
+          <a:bodyPr wrap="square" lIns="0" rIns="0" tIns="0" bIns="0" anchor="ctr">
+            <a:spAutoFit/>
+          </a:bodyPr>
+          <a:lstStyle/>
+          <a:p>
+            <a:pPr algn="l">
+              <a:spcAft>
+                <a:spcPts val="300"/>
+              </a:spcAft>
+            </a:pPr>
+            <a:r>
+              <a:rPr sz="950" b="1" i="0">
+                <a:solidFill>
+                  <a:srgbClr val="FFFFFF"/>
+                </a:solidFill>
+              </a:rPr>
+              <a:t>Partners: </a:t>
+            </a:r>
+            <a:r>
+              <a:rPr sz="950" b="0" i="0">
+                <a:solidFill>
+                  <a:srgbClr val="FFFFFF"/>
+                </a:solidFill>
+              </a:rPr>
+              <a:t>POLIMI · NTNU · SINTEF · LMS · CHALMERS · UNITN · RUG · MADE · TKNIKA · CECIMO · EUD · SUSTENO · MARTEL · INAIL   ·   www.skillaibility.eu</a:t>
+            </a:r>
+          </a:p>
+        </p:txBody>
+      </p:sp>
+    </p:spTree>
+  </p:cSld>
+  <p:clrMapOvr>
+    <a:masterClrMapping/>
+  </p:clrMapOvr>
+</p:sld>
+</file>
+
+<file path=ppt/slides/slide2.xml><?xml version="1.0" encoding="utf-8"?>
+<p:sld xmlns:a="http://schemas.openxmlformats.org/drawingml/2006/main" xmlns:p="http://schemas.openxmlformats.org/presentationml/2006/main" xmlns:r="http://schemas.openxmlformats.org/officeDocument/2006/relationships">
+  <p:cSld>
+    <p:spTree>
+      <p:nvGrpSpPr>
+        <p:cNvPr id="1" name=""/>
+        <p:cNvGrpSpPr/>
+        <p:nvPr/>
+      </p:nvGrpSpPr>
+      <p:grpSpPr/>
+      <p:sp>
+        <p:nvSpPr>
+          <p:cNvPr id="3" name="Title 2"/>
+          <p:cNvSpPr>
+            <a:spLocks noGrp="1"/>
+          </p:cNvSpPr>
+          <p:nvPr>
+            <p:ph type="title"/>
+          </p:nvPr>
+        </p:nvSpPr>
+        <p:spPr/>
+        <p:txBody>
+          <a:bodyPr/>
+          <a:lstStyle/>
+          <a:p>
+            <a:r>
+              <a:t>Chalmers contribution to WP3</a:t>
+            </a:r>
+          </a:p>
+        </p:txBody>
+      </p:sp>
+      <p:sp>
+        <p:nvSpPr>
+          <p:cNvPr id="4" name="TextBox 3"/>
+          <p:cNvSpPr txBox="1"/>
+          <p:nvPr/>
+        </p:nvSpPr>
+        <p:spPr>
+          <a:xfrm>
+            <a:off x="896112" y="1261872"/>
+            <a:ext cx="10332720" cy="365760"/>
+          </a:xfrm>
+          <a:prstGeom prst="rect">
+            <a:avLst/>
+          </a:prstGeom>
+          <a:noFill/>
+        </p:spPr>
+        <p:txBody>
+          <a:bodyPr wrap="square" lIns="0" rIns="0" tIns="0" bIns="0" anchor="t">
+            <a:spAutoFit/>
+          </a:bodyPr>
+          <a:lstStyle/>
+          <a:p>
+            <a:pPr algn="l">
+              <a:spcAft>
+                <a:spcPts val="300"/>
+              </a:spcAft>
+            </a:pPr>
+            <a:r>
+              <a:rPr sz="1200" b="0" i="1">
+                <a:solidFill>
+                  <a:srgbClr val="4A526B"/>
+                </a:solidFill>
+              </a:rPr>
+              <a:t>T3.2 Skill-gap mapping &amp; personas · T3.3 Assessment methodologies — from human-centric criteria to an interactive workshop toolkit</a:t>
+            </a:r>
+          </a:p>
+        </p:txBody>
+      </p:sp>
+      <p:sp>
+        <p:nvSpPr>
+          <p:cNvPr id="5" name="Rounded Rectangle 4"/>
+          <p:cNvSpPr/>
+          <p:nvPr/>
+        </p:nvSpPr>
+        <p:spPr>
+          <a:xfrm>
+            <a:off x="896112" y="1737360"/>
+            <a:ext cx="1170432" cy="1097280"/>
+          </a:xfrm>
+          <a:prstGeom prst="roundRect">
+            <a:avLst>
+              <a:gd name="adj" fmla="val 8000"/>
+            </a:avLst>
+          </a:prstGeom>
+          <a:solidFill>
+            <a:srgbClr val="EEF1F6"/>
+          </a:solidFill>
+          <a:ln>
+            <a:noFill/>
+          </a:ln>
+          <a:effectLst/>
+        </p:spPr>
+        <p:style>
+          <a:lnRef idx="1">
+            <a:schemeClr val="accent1"/>
+          </a:lnRef>
+          <a:fillRef idx="3">
+            <a:schemeClr val="accent1"/>
+          </a:fillRef>
+          <a:effectRef idx="2">
+            <a:schemeClr val="accent1"/>
+          </a:effectRef>
+          <a:fontRef idx="minor">
+            <a:schemeClr val="lt1"/>
+          </a:fontRef>
+        </p:style>
+        <p:txBody>
+          <a:bodyPr rtlCol="0" anchor="ctr"/>
+          <a:lstStyle/>
+          <a:p/>
+        </p:txBody>
+      </p:sp>
+      <p:sp>
+        <p:nvSpPr>
+          <p:cNvPr id="6" name="TextBox 5"/>
+          <p:cNvSpPr txBox="1"/>
+          <p:nvPr/>
+        </p:nvSpPr>
+        <p:spPr>
+          <a:xfrm>
+            <a:off x="896112" y="1764792"/>
+            <a:ext cx="1170432" cy="411480"/>
+          </a:xfrm>
+          <a:prstGeom prst="rect">
+            <a:avLst/>
+          </a:prstGeom>
+          <a:noFill/>
+        </p:spPr>
+        <p:txBody>
+          <a:bodyPr wrap="square" lIns="0" rIns="0" tIns="0" bIns="0" anchor="t">
+            <a:spAutoFit/>
+          </a:bodyPr>
+          <a:lstStyle/>
+          <a:p>
+            <a:pPr algn="ctr">
+              <a:spcAft>
+                <a:spcPts val="300"/>
+              </a:spcAft>
+            </a:pPr>
+            <a:r>
+              <a:rPr sz="2100" b="1" i="0">
+                <a:solidFill>
+                  <a:srgbClr val="0092CA"/>
+                </a:solidFill>
+              </a:rPr>
+              <a:t>5</a:t>
+            </a:r>
+          </a:p>
+        </p:txBody>
+      </p:sp>
+      <p:sp>
+        <p:nvSpPr>
+          <p:cNvPr id="7" name="TextBox 6"/>
+          <p:cNvSpPr txBox="1"/>
+          <p:nvPr/>
+        </p:nvSpPr>
+        <p:spPr>
+          <a:xfrm>
+            <a:off x="941832" y="2176272"/>
+            <a:ext cx="1078992" cy="329184"/>
+          </a:xfrm>
+          <a:prstGeom prst="rect">
+            <a:avLst/>
+          </a:prstGeom>
+          <a:noFill/>
+        </p:spPr>
+        <p:txBody>
+          <a:bodyPr wrap="square" lIns="0" rIns="0" tIns="0" bIns="0" anchor="t">
+            <a:spAutoFit/>
+          </a:bodyPr>
+          <a:lstStyle/>
+          <a:p>
+            <a:pPr algn="ctr">
+              <a:spcAft>
+                <a:spcPts val="0"/>
+              </a:spcAft>
+            </a:pPr>
+            <a:r>
+              <a:rPr sz="800" b="1" i="0">
+                <a:solidFill>
+                  <a:srgbClr val="0B1138"/>
+                </a:solidFill>
+              </a:rPr>
+              <a:t>publications</a:t>
+            </a:r>
+          </a:p>
+        </p:txBody>
+      </p:sp>
+      <p:sp>
+        <p:nvSpPr>
+          <p:cNvPr id="8" name="TextBox 7"/>
+          <p:cNvSpPr txBox="1"/>
+          <p:nvPr/>
+        </p:nvSpPr>
+        <p:spPr>
+          <a:xfrm>
+            <a:off x="941832" y="2505456"/>
+            <a:ext cx="1078992" cy="310896"/>
+          </a:xfrm>
+          <a:prstGeom prst="rect">
+            <a:avLst/>
+          </a:prstGeom>
+          <a:noFill/>
+        </p:spPr>
+        <p:txBody>
+          <a:bodyPr wrap="square" lIns="0" rIns="0" tIns="0" bIns="0" anchor="t">
+            <a:spAutoFit/>
+          </a:bodyPr>
+          <a:lstStyle/>
+          <a:p>
+            <a:pPr algn="ctr">
+              <a:spcAft>
+                <a:spcPts val="0"/>
+              </a:spcAft>
+            </a:pPr>
+            <a:r>
+              <a:rPr sz="700" b="0" i="0">
+                <a:solidFill>
+                  <a:srgbClr val="4A526B"/>
+                </a:solidFill>
+              </a:rPr>
+              <a:t>IFAC · APMS · SPS ×2 · PLM</a:t>
+            </a:r>
+          </a:p>
+        </p:txBody>
+      </p:sp>
+      <p:sp>
+        <p:nvSpPr>
+          <p:cNvPr id="9" name="Rounded Rectangle 8"/>
+          <p:cNvSpPr/>
+          <p:nvPr/>
+        </p:nvSpPr>
+        <p:spPr>
+          <a:xfrm>
+            <a:off x="2139696" y="1737360"/>
+            <a:ext cx="1170432" cy="1097280"/>
+          </a:xfrm>
+          <a:prstGeom prst="roundRect">
+            <a:avLst>
+              <a:gd name="adj" fmla="val 8000"/>
+            </a:avLst>
+          </a:prstGeom>
+          <a:solidFill>
+            <a:srgbClr val="EEF1F6"/>
+          </a:solidFill>
+          <a:ln>
+            <a:noFill/>
+          </a:ln>
+          <a:effectLst/>
+        </p:spPr>
+        <p:style>
+          <a:lnRef idx="1">
+            <a:schemeClr val="accent1"/>
+          </a:lnRef>
+          <a:fillRef idx="3">
+            <a:schemeClr val="accent1"/>
+          </a:fillRef>
+          <a:effectRef idx="2">
+            <a:schemeClr val="accent1"/>
+          </a:effectRef>
+          <a:fontRef idx="minor">
+            <a:schemeClr val="lt1"/>
+          </a:fontRef>
+        </p:style>
+        <p:txBody>
+          <a:bodyPr rtlCol="0" anchor="ctr"/>
+          <a:lstStyle/>
+          <a:p/>
+        </p:txBody>
+      </p:sp>
+      <p:sp>
+        <p:nvSpPr>
+          <p:cNvPr id="10" name="TextBox 9"/>
+          <p:cNvSpPr txBox="1"/>
+          <p:nvPr/>
+        </p:nvSpPr>
+        <p:spPr>
+          <a:xfrm>
+            <a:off x="2139696" y="1764792"/>
+            <a:ext cx="1170432" cy="411480"/>
+          </a:xfrm>
+          <a:prstGeom prst="rect">
+            <a:avLst/>
+          </a:prstGeom>
+          <a:noFill/>
+        </p:spPr>
+        <p:txBody>
+          <a:bodyPr wrap="square" lIns="0" rIns="0" tIns="0" bIns="0" anchor="t">
+            <a:spAutoFit/>
+          </a:bodyPr>
+          <a:lstStyle/>
+          <a:p>
+            <a:pPr algn="ctr">
+              <a:spcAft>
+                <a:spcPts val="300"/>
+              </a:spcAft>
+            </a:pPr>
+            <a:r>
+              <a:rPr sz="2100" b="1" i="0">
+                <a:solidFill>
+                  <a:srgbClr val="0092CA"/>
+                </a:solidFill>
+              </a:rPr>
+              <a:t>118</a:t>
+            </a:r>
+          </a:p>
+        </p:txBody>
+      </p:sp>
+      <p:sp>
+        <p:nvSpPr>
+          <p:cNvPr id="11" name="TextBox 10"/>
+          <p:cNvSpPr txBox="1"/>
+          <p:nvPr/>
+        </p:nvSpPr>
+        <p:spPr>
+          <a:xfrm>
+            <a:off x="2185415" y="2176272"/>
+            <a:ext cx="1078992" cy="329184"/>
+          </a:xfrm>
+          <a:prstGeom prst="rect">
+            <a:avLst/>
+          </a:prstGeom>
+          <a:noFill/>
+        </p:spPr>
+        <p:txBody>
+          <a:bodyPr wrap="square" lIns="0" rIns="0" tIns="0" bIns="0" anchor="t">
+            <a:spAutoFit/>
+          </a:bodyPr>
+          <a:lstStyle/>
+          <a:p>
+            <a:pPr algn="ctr">
+              <a:spcAft>
+                <a:spcPts val="0"/>
+              </a:spcAft>
+            </a:pPr>
+            <a:r>
+              <a:rPr sz="800" b="1" i="0">
+                <a:solidFill>
+                  <a:srgbClr val="0B1138"/>
+                </a:solidFill>
+              </a:rPr>
+              <a:t>workshop participants</a:t>
+            </a:r>
+          </a:p>
+        </p:txBody>
+      </p:sp>
+      <p:sp>
+        <p:nvSpPr>
+          <p:cNvPr id="12" name="TextBox 11"/>
+          <p:cNvSpPr txBox="1"/>
+          <p:nvPr/>
+        </p:nvSpPr>
+        <p:spPr>
+          <a:xfrm>
+            <a:off x="2185415" y="2505456"/>
+            <a:ext cx="1078992" cy="310896"/>
+          </a:xfrm>
+          <a:prstGeom prst="rect">
+            <a:avLst/>
+          </a:prstGeom>
+          <a:noFill/>
+        </p:spPr>
+        <p:txBody>
+          <a:bodyPr wrap="square" lIns="0" rIns="0" tIns="0" bIns="0" anchor="t">
+            <a:spAutoFit/>
+          </a:bodyPr>
+          <a:lstStyle/>
+          <a:p>
+            <a:pPr algn="ctr">
+              <a:spcAft>
+                <a:spcPts val="0"/>
+              </a:spcAft>
+            </a:pPr>
+            <a:r>
+              <a:rPr sz="700" b="0" i="0">
+                <a:solidFill>
+                  <a:srgbClr val="4A526B"/>
+                </a:solidFill>
+              </a:rPr>
+              <a:t>2 AIM co-creation events</a:t>
+            </a:r>
+          </a:p>
+        </p:txBody>
+      </p:sp>
+      <p:sp>
+        <p:nvSpPr>
+          <p:cNvPr id="13" name="Rounded Rectangle 12"/>
+          <p:cNvSpPr/>
+          <p:nvPr/>
+        </p:nvSpPr>
+        <p:spPr>
+          <a:xfrm>
+            <a:off x="3383280" y="1737360"/>
+            <a:ext cx="1170432" cy="1097280"/>
+          </a:xfrm>
+          <a:prstGeom prst="roundRect">
+            <a:avLst>
+              <a:gd name="adj" fmla="val 8000"/>
+            </a:avLst>
+          </a:prstGeom>
+          <a:solidFill>
+            <a:srgbClr val="EEF1F6"/>
+          </a:solidFill>
+          <a:ln>
+            <a:noFill/>
+          </a:ln>
+          <a:effectLst/>
+        </p:spPr>
+        <p:style>
+          <a:lnRef idx="1">
+            <a:schemeClr val="accent1"/>
+          </a:lnRef>
+          <a:fillRef idx="3">
+            <a:schemeClr val="accent1"/>
+          </a:fillRef>
+          <a:effectRef idx="2">
+            <a:schemeClr val="accent1"/>
+          </a:effectRef>
+          <a:fontRef idx="minor">
+            <a:schemeClr val="lt1"/>
+          </a:fontRef>
+        </p:style>
+        <p:txBody>
+          <a:bodyPr rtlCol="0" anchor="ctr"/>
+          <a:lstStyle/>
+          <a:p/>
+        </p:txBody>
+      </p:sp>
+      <p:sp>
+        <p:nvSpPr>
+          <p:cNvPr id="14" name="TextBox 13"/>
+          <p:cNvSpPr txBox="1"/>
+          <p:nvPr/>
+        </p:nvSpPr>
+        <p:spPr>
+          <a:xfrm>
+            <a:off x="3383280" y="1764792"/>
+            <a:ext cx="1170432" cy="411480"/>
+          </a:xfrm>
+          <a:prstGeom prst="rect">
+            <a:avLst/>
+          </a:prstGeom>
+          <a:noFill/>
+        </p:spPr>
+        <p:txBody>
+          <a:bodyPr wrap="square" lIns="0" rIns="0" tIns="0" bIns="0" anchor="t">
+            <a:spAutoFit/>
+          </a:bodyPr>
+          <a:lstStyle/>
+          <a:p>
+            <a:pPr algn="ctr">
+              <a:spcAft>
+                <a:spcPts val="300"/>
+              </a:spcAft>
+            </a:pPr>
+            <a:r>
+              <a:rPr sz="2100" b="1" i="0">
+                <a:solidFill>
+                  <a:srgbClr val="0092CA"/>
+                </a:solidFill>
+              </a:rPr>
+              <a:t>24</a:t>
+            </a:r>
+          </a:p>
+        </p:txBody>
+      </p:sp>
+      <p:sp>
+        <p:nvSpPr>
+          <p:cNvPr id="15" name="TextBox 14"/>
+          <p:cNvSpPr txBox="1"/>
+          <p:nvPr/>
+        </p:nvSpPr>
+        <p:spPr>
+          <a:xfrm>
+            <a:off x="3429000" y="2176272"/>
+            <a:ext cx="1078992" cy="329184"/>
+          </a:xfrm>
+          <a:prstGeom prst="rect">
+            <a:avLst/>
+          </a:prstGeom>
+          <a:noFill/>
+        </p:spPr>
+        <p:txBody>
+          <a:bodyPr wrap="square" lIns="0" rIns="0" tIns="0" bIns="0" anchor="t">
+            <a:spAutoFit/>
+          </a:bodyPr>
+          <a:lstStyle/>
+          <a:p>
+            <a:pPr algn="ctr">
+              <a:spcAft>
+                <a:spcPts val="0"/>
+              </a:spcAft>
+            </a:pPr>
+            <a:r>
+              <a:rPr sz="800" b="1" i="0">
+                <a:solidFill>
+                  <a:srgbClr val="0B1138"/>
+                </a:solidFill>
+              </a:rPr>
+              <a:t>survey respondents</a:t>
+            </a:r>
+          </a:p>
+        </p:txBody>
+      </p:sp>
+      <p:sp>
+        <p:nvSpPr>
+          <p:cNvPr id="16" name="TextBox 15"/>
+          <p:cNvSpPr txBox="1"/>
+          <p:nvPr/>
+        </p:nvSpPr>
+        <p:spPr>
+          <a:xfrm>
+            <a:off x="3429000" y="2505456"/>
+            <a:ext cx="1078992" cy="310896"/>
+          </a:xfrm>
+          <a:prstGeom prst="rect">
+            <a:avLst/>
+          </a:prstGeom>
+          <a:noFill/>
+        </p:spPr>
+        <p:txBody>
+          <a:bodyPr wrap="square" lIns="0" rIns="0" tIns="0" bIns="0" anchor="t">
+            <a:spAutoFit/>
+          </a:bodyPr>
+          <a:lstStyle/>
+          <a:p>
+            <a:pPr algn="ctr">
+              <a:spcAft>
+                <a:spcPts val="0"/>
+              </a:spcAft>
+            </a:pPr>
+            <a:r>
+              <a:rPr sz="700" b="0" i="0">
+                <a:solidFill>
+                  <a:srgbClr val="4A526B"/>
+                </a:solidFill>
+              </a:rPr>
+              <a:t>managers &amp; experts</a:t>
+            </a:r>
+          </a:p>
+        </p:txBody>
+      </p:sp>
+      <p:sp>
+        <p:nvSpPr>
+          <p:cNvPr id="17" name="Rounded Rectangle 16"/>
+          <p:cNvSpPr/>
+          <p:nvPr/>
+        </p:nvSpPr>
+        <p:spPr>
+          <a:xfrm>
+            <a:off x="4626864" y="1737360"/>
+            <a:ext cx="1170432" cy="1097280"/>
+          </a:xfrm>
+          <a:prstGeom prst="roundRect">
+            <a:avLst>
+              <a:gd name="adj" fmla="val 8000"/>
+            </a:avLst>
+          </a:prstGeom>
+          <a:solidFill>
+            <a:srgbClr val="EEF1F6"/>
+          </a:solidFill>
+          <a:ln>
+            <a:noFill/>
+          </a:ln>
+          <a:effectLst/>
+        </p:spPr>
+        <p:style>
+          <a:lnRef idx="1">
+            <a:schemeClr val="accent1"/>
+          </a:lnRef>
+          <a:fillRef idx="3">
+            <a:schemeClr val="accent1"/>
+          </a:fillRef>
+          <a:effectRef idx="2">
+            <a:schemeClr val="accent1"/>
+          </a:effectRef>
+          <a:fontRef idx="minor">
+            <a:schemeClr val="lt1"/>
+          </a:fontRef>
+        </p:style>
+        <p:txBody>
+          <a:bodyPr rtlCol="0" anchor="ctr"/>
+          <a:lstStyle/>
+          <a:p/>
+        </p:txBody>
+      </p:sp>
+      <p:sp>
+        <p:nvSpPr>
+          <p:cNvPr id="18" name="TextBox 17"/>
+          <p:cNvSpPr txBox="1"/>
+          <p:nvPr/>
+        </p:nvSpPr>
+        <p:spPr>
+          <a:xfrm>
+            <a:off x="4626864" y="1764792"/>
+            <a:ext cx="1170432" cy="411480"/>
+          </a:xfrm>
+          <a:prstGeom prst="rect">
+            <a:avLst/>
+          </a:prstGeom>
+          <a:noFill/>
+        </p:spPr>
+        <p:txBody>
+          <a:bodyPr wrap="square" lIns="0" rIns="0" tIns="0" bIns="0" anchor="t">
+            <a:spAutoFit/>
+          </a:bodyPr>
+          <a:lstStyle/>
+          <a:p>
+            <a:pPr algn="ctr">
+              <a:spcAft>
+                <a:spcPts val="300"/>
+              </a:spcAft>
+            </a:pPr>
+            <a:r>
+              <a:rPr sz="2100" b="1" i="0">
+                <a:solidFill>
+                  <a:srgbClr val="0092CA"/>
+                </a:solidFill>
+              </a:rPr>
+              <a:t>10</a:t>
+            </a:r>
+          </a:p>
+        </p:txBody>
+      </p:sp>
+      <p:sp>
+        <p:nvSpPr>
+          <p:cNvPr id="19" name="TextBox 18"/>
+          <p:cNvSpPr txBox="1"/>
+          <p:nvPr/>
+        </p:nvSpPr>
+        <p:spPr>
+          <a:xfrm>
+            <a:off x="4672584" y="2176272"/>
+            <a:ext cx="1078992" cy="329184"/>
+          </a:xfrm>
+          <a:prstGeom prst="rect">
+            <a:avLst/>
+          </a:prstGeom>
+          <a:noFill/>
+        </p:spPr>
+        <p:txBody>
+          <a:bodyPr wrap="square" lIns="0" rIns="0" tIns="0" bIns="0" anchor="t">
+            <a:spAutoFit/>
+          </a:bodyPr>
+          <a:lstStyle/>
+          <a:p>
+            <a:pPr algn="ctr">
+              <a:spcAft>
+                <a:spcPts val="0"/>
+              </a:spcAft>
+            </a:pPr>
+            <a:r>
+              <a:rPr sz="800" b="1" i="0">
+                <a:solidFill>
+                  <a:srgbClr val="0B1138"/>
+                </a:solidFill>
+              </a:rPr>
+              <a:t>operator interviews</a:t>
+            </a:r>
+          </a:p>
+        </p:txBody>
+      </p:sp>
+      <p:sp>
+        <p:nvSpPr>
+          <p:cNvPr id="20" name="TextBox 19"/>
+          <p:cNvSpPr txBox="1"/>
+          <p:nvPr/>
+        </p:nvSpPr>
+        <p:spPr>
+          <a:xfrm>
+            <a:off x="4672584" y="2505456"/>
+            <a:ext cx="1078992" cy="310896"/>
+          </a:xfrm>
+          <a:prstGeom prst="rect">
+            <a:avLst/>
+          </a:prstGeom>
+          <a:noFill/>
+        </p:spPr>
+        <p:txBody>
+          <a:bodyPr wrap="square" lIns="0" rIns="0" tIns="0" bIns="0" anchor="t">
+            <a:spAutoFit/>
+          </a:bodyPr>
+          <a:lstStyle/>
+          <a:p>
+            <a:pPr algn="ctr">
+              <a:spcAft>
+                <a:spcPts val="0"/>
+              </a:spcAft>
+            </a:pPr>
+            <a:r>
+              <a:rPr sz="700" b="0" i="0">
+                <a:solidFill>
+                  <a:srgbClr val="4A526B"/>
+                </a:solidFill>
+              </a:rPr>
+              <a:t>SSAB · System 3R · Natl. Gummi</a:t>
+            </a:r>
+          </a:p>
+        </p:txBody>
+      </p:sp>
+      <p:sp>
+        <p:nvSpPr>
+          <p:cNvPr id="21" name="Rounded Rectangle 20"/>
+          <p:cNvSpPr/>
+          <p:nvPr/>
+        </p:nvSpPr>
+        <p:spPr>
+          <a:xfrm>
+            <a:off x="896112" y="2971800"/>
+            <a:ext cx="4892040" cy="3200400"/>
+          </a:xfrm>
+          <a:prstGeom prst="roundRect">
+            <a:avLst>
+              <a:gd name="adj" fmla="val 8000"/>
+            </a:avLst>
+          </a:prstGeom>
+          <a:solidFill>
+            <a:srgbClr val="E3F6FD"/>
+          </a:solidFill>
+          <a:ln>
+            <a:noFill/>
+          </a:ln>
+          <a:effectLst/>
+        </p:spPr>
+        <p:style>
+          <a:lnRef idx="1">
+            <a:schemeClr val="accent1"/>
+          </a:lnRef>
+          <a:fillRef idx="3">
+            <a:schemeClr val="accent1"/>
+          </a:fillRef>
+          <a:effectRef idx="2">
+            <a:schemeClr val="accent1"/>
+          </a:effectRef>
+          <a:fontRef idx="minor">
+            <a:schemeClr val="lt1"/>
+          </a:fontRef>
+        </p:style>
+        <p:txBody>
+          <a:bodyPr rtlCol="0" anchor="ctr"/>
+          <a:lstStyle/>
+          <a:p/>
+        </p:txBody>
+      </p:sp>
+      <p:sp>
+        <p:nvSpPr>
+          <p:cNvPr id="22" name="TextBox 21"/>
+          <p:cNvSpPr txBox="1"/>
+          <p:nvPr/>
+        </p:nvSpPr>
+        <p:spPr>
+          <a:xfrm>
+            <a:off x="1078992" y="3063240"/>
+            <a:ext cx="4526279" cy="320040"/>
+          </a:xfrm>
+          <a:prstGeom prst="rect">
+            <a:avLst/>
+          </a:prstGeom>
+          <a:noFill/>
+        </p:spPr>
+        <p:txBody>
+          <a:bodyPr wrap="square" lIns="0" rIns="0" tIns="0" bIns="0" anchor="t">
+            <a:spAutoFit/>
+          </a:bodyPr>
+          <a:lstStyle/>
+          <a:p>
+            <a:pPr algn="l">
+              <a:spcAft>
+                <a:spcPts val="300"/>
+              </a:spcAft>
+            </a:pPr>
+            <a:r>
+              <a:rPr sz="1250" b="1" i="0">
+                <a:solidFill>
+                  <a:srgbClr val="0092CA"/>
+                </a:solidFill>
+              </a:rPr>
+              <a:t>Research results feeding D3.2</a:t>
+            </a:r>
+          </a:p>
+        </p:txBody>
+      </p:sp>
+      <p:sp>
+        <p:nvSpPr>
+          <p:cNvPr id="23" name="TextBox 22"/>
+          <p:cNvSpPr txBox="1"/>
+          <p:nvPr/>
+        </p:nvSpPr>
+        <p:spPr>
+          <a:xfrm>
+            <a:off x="1078992" y="3429000"/>
+            <a:ext cx="4526279" cy="2697480"/>
+          </a:xfrm>
+          <a:prstGeom prst="rect">
+            <a:avLst/>
+          </a:prstGeom>
+          <a:noFill/>
+        </p:spPr>
+        <p:txBody>
+          <a:bodyPr wrap="square" lIns="0" rIns="0" tIns="0" bIns="0" anchor="t">
+            <a:spAutoFit/>
+          </a:bodyPr>
+          <a:lstStyle/>
+          <a:p>
+            <a:pPr algn="l" marL="164592" indent="-164592">
+              <a:spcAft>
+                <a:spcPts val="400"/>
+              </a:spcAft>
+              <a:buChar char="•"/>
+            </a:pPr>
+            <a:r>
+              <a:rPr sz="950" b="1" i="0">
+                <a:solidFill>
+                  <a:srgbClr val="0B1138"/>
+                </a:solidFill>
+              </a:rPr>
+              <a:t>Worker-demand taxonomy</a:t>
+            </a:r>
+            <a:r>
+              <a:rPr sz="950" b="0" i="0">
+                <a:solidFill>
+                  <a:srgbClr val="0B1138"/>
+                </a:solidFill>
+              </a:rPr>
+              <a:t> – core (physical / cognitive / sensing) and contextual demands (leadership, training, social inclusion) · SPS 2026</a:t>
+            </a:r>
+          </a:p>
+          <a:p>
+            <a:pPr algn="l" marL="164592" indent="-164592">
+              <a:spcAft>
+                <a:spcPts val="400"/>
+              </a:spcAft>
+              <a:buChar char="•"/>
+            </a:pPr>
+            <a:r>
+              <a:rPr sz="950" b="1" i="0">
+                <a:solidFill>
+                  <a:srgbClr val="0B1138"/>
+                </a:solidFill>
+              </a:rPr>
+              <a:t>Human–AI collaboration principles</a:t>
+            </a:r>
+            <a:r>
+              <a:rPr sz="950" b="0" i="0">
+                <a:solidFill>
+                  <a:srgbClr val="0B1138"/>
+                </a:solidFill>
+              </a:rPr>
+              <a:t> – trust, autonomy, usability for shared tasks · APMS 2026</a:t>
+            </a:r>
+          </a:p>
+          <a:p>
+            <a:pPr algn="l" marL="164592" indent="-164592">
+              <a:spcAft>
+                <a:spcPts val="400"/>
+              </a:spcAft>
+              <a:buChar char="•"/>
+            </a:pPr>
+            <a:r>
+              <a:rPr sz="950" b="1" i="0">
+                <a:solidFill>
+                  <a:srgbClr val="0B1138"/>
+                </a:solidFill>
+              </a:rPr>
+              <a:t>Five vulnerable-group personas</a:t>
+            </a:r>
+            <a:r>
+              <a:rPr sz="950" b="0" i="0">
+                <a:solidFill>
+                  <a:srgbClr val="0B1138"/>
+                </a:solidFill>
+              </a:rPr>
+              <a:t> + multimodal-redundancy design principle · PLM 2026</a:t>
+            </a:r>
+          </a:p>
+          <a:p>
+            <a:pPr algn="l" marL="164592" indent="-164592">
+              <a:spcAft>
+                <a:spcPts val="400"/>
+              </a:spcAft>
+              <a:buChar char="•"/>
+            </a:pPr>
+            <a:r>
+              <a:rPr sz="950" b="1" i="0">
+                <a:solidFill>
+                  <a:srgbClr val="0B1138"/>
+                </a:solidFill>
+              </a:rPr>
+              <a:t>Operator evidence</a:t>
+            </a:r>
+            <a:r>
+              <a:rPr sz="950" b="0" i="0">
+                <a:solidFill>
+                  <a:srgbClr val="0B1138"/>
+                </a:solidFill>
+              </a:rPr>
+              <a:t> – 10 interviews → 6 human-centric factors, 5 implementation principles (involvement, transparency, social learning, learning by doing, continuous governance)</a:t>
+            </a:r>
+          </a:p>
+          <a:p>
+            <a:pPr algn="l" marL="164592" indent="-164592">
+              <a:spcAft>
+                <a:spcPts val="400"/>
+              </a:spcAft>
+              <a:buChar char="•"/>
+            </a:pPr>
+            <a:r>
+              <a:rPr sz="950" b="1" i="0">
+                <a:solidFill>
+                  <a:srgbClr val="0B1138"/>
+                </a:solidFill>
+              </a:rPr>
+              <a:t>Actionable requirement lists</a:t>
+            </a:r>
+            <a:r>
+              <a:rPr sz="950" b="0" i="0">
+                <a:solidFill>
+                  <a:srgbClr val="0B1138"/>
+                </a:solidFill>
+              </a:rPr>
+              <a:t> – Task characteristics TA1–9, Technology requirements TE1–16, Organisational conditions OR1–10, mapped per worker group × learning pathway</a:t>
+            </a:r>
+          </a:p>
+          <a:p>
+            <a:pPr algn="l" marL="164592" indent="-164592">
+              <a:spcAft>
+                <a:spcPts val="400"/>
+              </a:spcAft>
+              <a:buChar char="•"/>
+            </a:pPr>
+            <a:r>
+              <a:rPr sz="950" b="1" i="0">
+                <a:solidFill>
+                  <a:srgbClr val="0B1138"/>
+                </a:solidFill>
+              </a:rPr>
+              <a:t>Assessment building blocks</a:t>
+            </a:r>
+            <a:r>
+              <a:rPr sz="950" b="0" i="0">
+                <a:solidFill>
+                  <a:srgbClr val="0B1138"/>
+                </a:solidFill>
+              </a:rPr>
+              <a:t> – user journeys, goals &amp; metrics, micro → macro KPIs, human value–technology fit</a:t>
+            </a:r>
+          </a:p>
+        </p:txBody>
+      </p:sp>
+      <p:sp>
+        <p:nvSpPr>
+          <p:cNvPr id="24" name="Rounded Rectangle 23"/>
+          <p:cNvSpPr/>
+          <p:nvPr/>
+        </p:nvSpPr>
+        <p:spPr>
+          <a:xfrm>
+            <a:off x="5989320" y="1737360"/>
+            <a:ext cx="5257800" cy="4434840"/>
+          </a:xfrm>
+          <a:prstGeom prst="roundRect">
+            <a:avLst>
+              <a:gd name="adj" fmla="val 5000"/>
+            </a:avLst>
+          </a:prstGeom>
+          <a:solidFill>
+            <a:srgbClr val="FFFFFF"/>
+          </a:solidFill>
+          <a:ln w="25400">
+            <a:solidFill>
+              <a:srgbClr val="09BDF0"/>
+            </a:solidFill>
+          </a:ln>
+          <a:effectLst/>
+        </p:spPr>
+        <p:style>
+          <a:lnRef idx="1">
+            <a:schemeClr val="accent1"/>
+          </a:lnRef>
+          <a:fillRef idx="3">
+            <a:schemeClr val="accent1"/>
+          </a:fillRef>
+          <a:effectRef idx="2">
+            <a:schemeClr val="accent1"/>
+          </a:effectRef>
+          <a:fontRef idx="minor">
+            <a:schemeClr val="lt1"/>
+          </a:fontRef>
+        </p:style>
+        <p:txBody>
+          <a:bodyPr rtlCol="0" anchor="ctr"/>
+          <a:lstStyle/>
+          <a:p/>
+        </p:txBody>
+      </p:sp>
+      <p:sp>
+        <p:nvSpPr>
+          <p:cNvPr id="25" name="Rounded Rectangle 24"/>
+          <p:cNvSpPr/>
+          <p:nvPr/>
+        </p:nvSpPr>
+        <p:spPr>
+          <a:xfrm>
+            <a:off x="6172200" y="1572768"/>
+            <a:ext cx="2194560" cy="329184"/>
+          </a:xfrm>
+          <a:prstGeom prst="roundRect">
+            <a:avLst>
+              <a:gd name="adj" fmla="val 50000"/>
+            </a:avLst>
+          </a:prstGeom>
+          <a:solidFill>
+            <a:srgbClr val="09BDF0"/>
+          </a:solidFill>
+          <a:ln>
+            <a:noFill/>
+          </a:ln>
+          <a:effectLst/>
+        </p:spPr>
+        <p:style>
+          <a:lnRef idx="1">
+            <a:schemeClr val="accent1"/>
+          </a:lnRef>
+          <a:fillRef idx="3">
+            <a:schemeClr val="accent1"/>
+          </a:fillRef>
+          <a:effectRef idx="2">
+            <a:schemeClr val="accent1"/>
+          </a:effectRef>
+          <a:fontRef idx="minor">
+            <a:schemeClr val="lt1"/>
+          </a:fontRef>
+        </p:style>
+        <p:txBody>
+          <a:bodyPr rtlCol="0" anchor="ctr"/>
+          <a:lstStyle/>
+          <a:p/>
+        </p:txBody>
+      </p:sp>
+      <p:sp>
+        <p:nvSpPr>
+          <p:cNvPr id="26" name="TextBox 25"/>
+          <p:cNvSpPr txBox="1"/>
+          <p:nvPr/>
+        </p:nvSpPr>
+        <p:spPr>
+          <a:xfrm>
+            <a:off x="6172200" y="1572768"/>
+            <a:ext cx="2194560" cy="329184"/>
+          </a:xfrm>
+          <a:prstGeom prst="rect">
+            <a:avLst/>
+          </a:prstGeom>
+          <a:noFill/>
+        </p:spPr>
+        <p:txBody>
+          <a:bodyPr wrap="square" lIns="0" rIns="0" tIns="0" bIns="0" anchor="ctr">
+            <a:spAutoFit/>
+          </a:bodyPr>
+          <a:lstStyle/>
+          <a:p>
+            <a:pPr algn="ctr">
+              <a:spcAft>
+                <a:spcPts val="300"/>
+              </a:spcAft>
+            </a:pPr>
+            <a:r>
+              <a:rPr sz="1000" b="1" i="0">
+                <a:solidFill>
+                  <a:srgbClr val="0B1138"/>
+                </a:solidFill>
+              </a:rPr>
+              <a:t>MAIN OUTCOME</a:t>
+            </a:r>
+          </a:p>
+        </p:txBody>
+      </p:sp>
+      <p:sp>
+        <p:nvSpPr>
+          <p:cNvPr id="27" name="TextBox 26"/>
+          <p:cNvSpPr txBox="1"/>
+          <p:nvPr/>
+        </p:nvSpPr>
+        <p:spPr>
+          <a:xfrm>
+            <a:off x="6217920" y="1993392"/>
+            <a:ext cx="4800600" cy="411480"/>
+          </a:xfrm>
+          <a:prstGeom prst="rect">
+            <a:avLst/>
+          </a:prstGeom>
+          <a:noFill/>
+        </p:spPr>
+        <p:txBody>
+          <a:bodyPr wrap="square" lIns="0" rIns="0" tIns="0" bIns="0" anchor="t">
+            <a:spAutoFit/>
+          </a:bodyPr>
+          <a:lstStyle/>
+          <a:p>
+            <a:pPr algn="l">
+              <a:spcAft>
+                <a:spcPts val="300"/>
+              </a:spcAft>
+            </a:pPr>
+            <a:r>
+              <a:rPr sz="1800" b="1" i="0">
+                <a:solidFill>
+                  <a:srgbClr val="0B1138"/>
+                </a:solidFill>
+              </a:rPr>
+              <a:t>Interactive Workshop Toolkit</a:t>
+            </a:r>
+          </a:p>
+        </p:txBody>
+      </p:sp>
+      <p:sp>
+        <p:nvSpPr>
+          <p:cNvPr id="28" name="TextBox 27"/>
+          <p:cNvSpPr txBox="1"/>
+          <p:nvPr/>
+        </p:nvSpPr>
+        <p:spPr>
+          <a:xfrm>
+            <a:off x="6217920" y="2395728"/>
+            <a:ext cx="4800600" cy="320040"/>
+          </a:xfrm>
+          <a:prstGeom prst="rect">
+            <a:avLst/>
+          </a:prstGeom>
+          <a:noFill/>
+        </p:spPr>
+        <p:txBody>
+          <a:bodyPr wrap="square" lIns="0" rIns="0" tIns="0" bIns="0" anchor="t">
+            <a:spAutoFit/>
+          </a:bodyPr>
+          <a:lstStyle/>
+          <a:p>
+            <a:pPr algn="l">
+              <a:spcAft>
+                <a:spcPts val="300"/>
+              </a:spcAft>
+            </a:pPr>
+            <a:r>
+              <a:rPr sz="1000" b="0" i="1">
+                <a:solidFill>
+                  <a:srgbClr val="4A526B"/>
+                </a:solidFill>
+              </a:rPr>
+              <a:t>Turns the WP3 models into a browser-based, data-collecting workshop – no login, no install.</a:t>
+            </a:r>
+          </a:p>
+        </p:txBody>
+      </p:sp>
+      <p:sp>
+        <p:nvSpPr>
+          <p:cNvPr id="29" name="Rounded Rectangle 28"/>
+          <p:cNvSpPr/>
+          <p:nvPr/>
+        </p:nvSpPr>
+        <p:spPr>
+          <a:xfrm>
+            <a:off x="6172200" y="2743200"/>
+            <a:ext cx="2606040" cy="1719072"/>
+          </a:xfrm>
+          <a:prstGeom prst="roundRect">
+            <a:avLst>
+              <a:gd name="adj" fmla="val 8000"/>
+            </a:avLst>
+          </a:prstGeom>
+          <a:solidFill>
+            <a:srgbClr val="D8DEE8"/>
+          </a:solidFill>
+          <a:ln>
+            <a:noFill/>
+          </a:ln>
+          <a:effectLst/>
+        </p:spPr>
+        <p:style>
+          <a:lnRef idx="1">
+            <a:schemeClr val="accent1"/>
+          </a:lnRef>
+          <a:fillRef idx="3">
+            <a:schemeClr val="accent1"/>
+          </a:fillRef>
+          <a:effectRef idx="2">
+            <a:schemeClr val="accent1"/>
+          </a:effectRef>
+          <a:fontRef idx="minor">
+            <a:schemeClr val="lt1"/>
+          </a:fontRef>
+        </p:style>
+        <p:txBody>
+          <a:bodyPr rtlCol="0" anchor="ctr"/>
+          <a:lstStyle/>
+          <a:p/>
+        </p:txBody>
+      </p:sp>
       <p:pic>
         <p:nvPicPr>
           <p:cNvPr id="30" name="Picture 29" descr="s_canvas.png"/>
@@ -9008,8 +10491,8 @@
         </p:nvSpPr>
         <p:spPr>
           <a:xfrm>
-            <a:off x="6217920" y="4526280"/>
-            <a:ext cx="4800600" cy="1600200"/>
+            <a:off x="6217920" y="4480560"/>
+            <a:ext cx="3566160" cy="1417320"/>
           </a:xfrm>
           <a:prstGeom prst="rect">
             <a:avLst/>
@@ -9024,12 +10507,12 @@
           <a:p>
             <a:pPr algn="l" marL="164592" indent="-164592">
               <a:spcAft>
-                <a:spcPts val="300"/>
+                <a:spcPts val="200"/>
               </a:spcAft>
               <a:buChar char="•"/>
             </a:pPr>
             <a:r>
-              <a:rPr sz="900" b="1" i="0">
+              <a:rPr sz="850" b="1" i="0">
                 <a:solidFill>
                   <a:srgbClr val="0B1138"/>
                 </a:solidFill>
@@ -9037,23 +10520,23 @@
               <a:t>Interconnected: </a:t>
             </a:r>
             <a:r>
-              <a:rPr sz="900" b="0" i="0">
+              <a:rPr sz="850" b="0" i="0">
                 <a:solidFill>
                   <a:srgbClr val="0B1138"/>
                 </a:solidFill>
               </a:rPr>
-              <a:t>shared worker groups, learning pathways and TA / TE / OR lists; canvas and solution canvas mirrored live</a:t>
+              <a:t>shared worker groups, pathways and TA / TE / OR lists; canvases mirrored live</a:t>
             </a:r>
           </a:p>
           <a:p>
             <a:pPr algn="l" marL="164592" indent="-164592">
               <a:spcAft>
-                <a:spcPts val="300"/>
+                <a:spcPts val="200"/>
               </a:spcAft>
               <a:buChar char="•"/>
             </a:pPr>
             <a:r>
-              <a:rPr sz="900" b="1" i="0">
+              <a:rPr sz="850" b="1" i="0">
                 <a:solidFill>
                   <a:srgbClr val="0B1138"/>
                 </a:solidFill>
@@ -9061,23 +10544,23 @@
               <a:t>Guided flows: </a:t>
             </a:r>
             <a:r>
-              <a:rPr sz="900" b="0" i="0">
+              <a:rPr sz="850" b="0" i="0">
                 <a:solidFill>
                   <a:srgbClr val="0B1138"/>
                 </a:solidFill>
               </a:rPr>
-              <a:t>Industrial (2 steps, 40–60 min) and Professional (4 steps, 65–90 min), instructions and timing at every step</a:t>
+              <a:t>Industrial (2 steps, 40–60 min) · Professional (4 steps, 65–90 min), timed instructions</a:t>
             </a:r>
           </a:p>
           <a:p>
             <a:pPr algn="l" marL="164592" indent="-164592">
               <a:spcAft>
-                <a:spcPts val="300"/>
+                <a:spcPts val="200"/>
               </a:spcAft>
               <a:buChar char="•"/>
             </a:pPr>
             <a:r>
-              <a:rPr sz="900" b="1" i="0">
+              <a:rPr sz="850" b="1" i="0">
                 <a:solidFill>
                   <a:srgbClr val="0B1138"/>
                 </a:solidFill>
@@ -9085,23 +10568,23 @@
               <a:t>Automated data collection: </a:t>
             </a:r>
             <a:r>
-              <a:rPr sz="900" b="0" i="0">
+              <a:rPr sz="850" b="0" i="0">
                 <a:solidFill>
                   <a:srgbClr val="0B1138"/>
                 </a:solidFill>
               </a:rPr>
-              <a:t>one Submit → Google Sheet, analysis-ready tabs, Excel workbook emailed to the team</a:t>
+              <a:t>one Submit → Google Sheet + Excel workbook emailed to the team</a:t>
             </a:r>
           </a:p>
           <a:p>
             <a:pPr algn="l" marL="164592" indent="-164592">
               <a:spcAft>
-                <a:spcPts val="300"/>
+                <a:spcPts val="200"/>
               </a:spcAft>
               <a:buChar char="•"/>
             </a:pPr>
             <a:r>
-              <a:rPr sz="900" b="1" i="0">
+              <a:rPr sz="850" b="1" i="0">
                 <a:solidFill>
                   <a:srgbClr val="0B1138"/>
                 </a:solidFill>
@@ -9109,19 +10592,81 @@
               <a:t>Validated: </a:t>
             </a:r>
             <a:r>
-              <a:rPr sz="900" b="0" i="0">
+              <a:rPr sz="850" b="0" i="0">
                 <a:solidFill>
                   <a:srgbClr val="0B1138"/>
                 </a:solidFill>
               </a:rPr>
-              <a:t>canvas piloted with 50 AIM participants – praised for collaboration, guided brainstorming, clear steps</a:t>
-            </a:r>
-          </a:p>
-        </p:txBody>
-      </p:sp>
-      <p:sp>
-        <p:nvSpPr>
-          <p:cNvPr id="44" name="TextBox 43"/>
+              <a:t>canvas piloted with 50 AIM participants – praised for collaboration and guided brainstorming</a:t>
+            </a:r>
+          </a:p>
+        </p:txBody>
+      </p:sp>
+      <p:pic>
+        <p:nvPicPr>
+          <p:cNvPr id="44" name="Picture 43" descr="qr_start.png"/>
+          <p:cNvPicPr>
+            <a:picLocks noChangeAspect="1"/>
+          </p:cNvPicPr>
+          <p:nvPr/>
+        </p:nvPicPr>
+        <p:blipFill>
+          <a:blip r:embed="rId3"/>
+          <a:stretch>
+            <a:fillRect/>
+          </a:stretch>
+        </p:blipFill>
+        <p:spPr>
+          <a:xfrm>
+            <a:off x="9875520" y="4434840"/>
+            <a:ext cx="1188720" cy="1188720"/>
+          </a:xfrm>
+          <a:prstGeom prst="rect">
+            <a:avLst/>
+          </a:prstGeom>
+        </p:spPr>
+      </p:pic>
+      <p:sp>
+        <p:nvSpPr>
+          <p:cNvPr id="45" name="TextBox 44"/>
+          <p:cNvSpPr txBox="1"/>
+          <p:nvPr/>
+        </p:nvSpPr>
+        <p:spPr>
+          <a:xfrm>
+            <a:off x="9784080" y="5623560"/>
+            <a:ext cx="1371600" cy="182880"/>
+          </a:xfrm>
+          <a:prstGeom prst="rect">
+            <a:avLst/>
+          </a:prstGeom>
+          <a:noFill/>
+        </p:spPr>
+        <p:txBody>
+          <a:bodyPr wrap="square" lIns="0" rIns="0" tIns="0" bIns="0" anchor="t">
+            <a:spAutoFit/>
+          </a:bodyPr>
+          <a:lstStyle/>
+          <a:p>
+            <a:pPr algn="ctr">
+              <a:spcAft>
+                <a:spcPts val="300"/>
+              </a:spcAft>
+            </a:pPr>
+            <a:r>
+              <a:rPr sz="800" b="1" i="0">
+                <a:solidFill>
+                  <a:srgbClr val="0B1138"/>
+                </a:solidFill>
+              </a:rPr>
+              <a:t>Scan to open</a:t>
+            </a:r>
+          </a:p>
+        </p:txBody>
+      </p:sp>
+      <p:sp>
+        <p:nvSpPr>
+          <p:cNvPr id="46" name="TextBox 45"/>
           <p:cNvSpPr txBox="1"/>
           <p:nvPr/>
         </p:nvSpPr>
@@ -9159,7 +10704,7 @@
       </p:sp>
       <p:sp>
         <p:nvSpPr>
-          <p:cNvPr id="45" name="Rounded Rectangle 44"/>
+          <p:cNvPr id="47" name="Rounded Rectangle 46"/>
           <p:cNvSpPr/>
           <p:nvPr/>
         </p:nvSpPr>
@@ -9203,7 +10748,7 @@
       </p:sp>
       <p:sp>
         <p:nvSpPr>
-          <p:cNvPr id="46" name="TextBox 45"/>
+          <p:cNvPr id="48" name="TextBox 47"/>
           <p:cNvSpPr txBox="1"/>
           <p:nvPr/>
         </p:nvSpPr>

</xml_diff>